<commit_message>
Enlarge logo 50%, swap numeral watermark for the icon mark
- Logo lockup (both light-background image and dark-background
  icon+typeset variant) scaled up 1.5x per feedback that it read too
  small; reflowed the top-of-slide layout on every content slide across
  both decks so titles/tables/photo grids clear the larger footprint.
- Replaced the oversized "0"-style ghost numeral watermark with the real
  icon mark at very low opacity (assets/logo/valletta-mark-ghost.png,
  alpha baked in via Pillow rather than relying on pptxgenjs image
  transparency, for reliable cross-renderer output). Same mark on every
  slide now, since it's a brand texture rather than page numbering.

Co-Authored-By: Claude Sonnet 5 <noreply@anthropic.com>
Claude-Session: https://claude.ai/code/session_01S91ijwKhvpV957ne7Bvxde
</commit_message>
<xml_diff>
--- a/decks/Valletta_DOI_OSSTP_Capability_Overview.pptx
+++ b/decks/Valletta_DOI_OSSTP_Capability_Overview.pptx
@@ -1320,48 +1320,9 @@
           <a:chExt cx="0" cy="0"/>
         </a:xfrm>
       </p:grpSpPr>
-      <p:sp>
-        <p:nvSpPr>
-          <p:cNvPr id="2" name="Text 0"/>
-          <p:cNvSpPr txBox="1"/>
-          <p:nvPr/>
-        </p:nvSpPr>
-        <p:spPr>
-          <a:xfrm>
-            <a:off x="6949440" y="0"/>
-            <a:ext cx="5486400" cy="6858000"/>
-          </a:xfrm>
-          <a:prstGeom prst="rect">
-            <a:avLst/>
-          </a:prstGeom>
-          <a:noFill/>
-          <a:ln/>
-        </p:spPr>
-        <p:txBody>
-          <a:bodyPr wrap="square" lIns="0" tIns="0" rIns="0" bIns="0" rtlCol="0" anchor="t"/>
-          <a:lstStyle/>
-          <a:p>
-            <a:pPr algn="r" indent="0" marL="0">
-              <a:buNone/>
-            </a:pPr>
-            <a:r>
-              <a:rPr lang="en-US" sz="36000" b="1" dirty="0">
-                <a:solidFill>
-                  <a:srgbClr val="141414"/>
-                </a:solidFill>
-                <a:latin typeface="Cambria" pitchFamily="34" charset="0"/>
-                <a:ea typeface="Cambria" pitchFamily="34" charset="-122"/>
-                <a:cs typeface="Cambria" pitchFamily="34" charset="-120"/>
-              </a:rPr>
-              <a:t>01</a:t>
-            </a:r>
-            <a:endParaRPr lang="en-US" sz="36000" dirty="0"/>
-          </a:p>
-        </p:txBody>
-      </p:sp>
       <p:pic>
         <p:nvPicPr>
-          <p:cNvPr id="3" name="Image 0" descr="/home/user/valletta-design-system/assets/logo/valletta-mark.png">    </p:cNvPr>
+          <p:cNvPr id="2" name="Image 0" descr="/home/user/valletta-design-system/assets/logo/valletta-mark-ghost.png">    </p:cNvPr>
           <p:cNvPicPr>
             <a:picLocks noChangeAspect="1"/>
           </p:cNvPicPr>
@@ -1375,8 +1336,32 @@
         </p:blipFill>
         <p:spPr>
           <a:xfrm>
+            <a:off x="7891272" y="502920"/>
+            <a:ext cx="5486400" cy="5839260"/>
+          </a:xfrm>
+          <a:prstGeom prst="rect">
+            <a:avLst/>
+          </a:prstGeom>
+        </p:spPr>
+      </p:pic>
+      <p:pic>
+        <p:nvPicPr>
+          <p:cNvPr id="3" name="Image 1" descr="/home/user/valletta-design-system/assets/logo/valletta-mark.png">    </p:cNvPr>
+          <p:cNvPicPr>
+            <a:picLocks noChangeAspect="1"/>
+          </p:cNvPicPr>
+          <p:nvPr/>
+        </p:nvPicPr>
+        <p:blipFill>
+          <a:blip r:embed="rId2"/>
+          <a:stretch>
+            <a:fillRect/>
+          </a:stretch>
+        </p:blipFill>
+        <p:spPr>
+          <a:xfrm>
             <a:off x="457200" y="365760"/>
-            <a:ext cx="365760" cy="389284"/>
+            <a:ext cx="548640" cy="583926"/>
           </a:xfrm>
           <a:prstGeom prst="rect">
             <a:avLst/>
@@ -1385,14 +1370,14 @@
       </p:pic>
       <p:sp>
         <p:nvSpPr>
-          <p:cNvPr id="4" name="Text 1"/>
-          <p:cNvSpPr txBox="1"/>
-          <p:nvPr/>
-        </p:nvSpPr>
-        <p:spPr>
-          <a:xfrm>
-            <a:off x="932688" y="329184"/>
-            <a:ext cx="2926080" cy="274320"/>
+          <p:cNvPr id="4" name="Text 0"/>
+          <p:cNvSpPr txBox="1"/>
+          <p:nvPr/>
+        </p:nvSpPr>
+        <p:spPr>
+          <a:xfrm>
+            <a:off x="1170432" y="347472"/>
+            <a:ext cx="3291840" cy="402336"/>
           </a:xfrm>
           <a:prstGeom prst="rect">
             <a:avLst/>
@@ -1408,7 +1393,7 @@
               <a:buNone/>
             </a:pPr>
             <a:r>
-              <a:rPr lang="en-US" sz="1500" spc="200" kern="0" dirty="0">
+              <a:rPr lang="en-US" sz="2200" spc="200" kern="0" dirty="0">
                 <a:solidFill>
                   <a:srgbClr val="FFFFFF"/>
                 </a:solidFill>
@@ -1418,20 +1403,20 @@
               </a:rPr>
               <a:t>VALLETTA</a:t>
             </a:r>
-            <a:endParaRPr lang="en-US" sz="1500" dirty="0"/>
-          </a:p>
-        </p:txBody>
-      </p:sp>
-      <p:sp>
-        <p:nvSpPr>
-          <p:cNvPr id="5" name="Text 2"/>
-          <p:cNvSpPr txBox="1"/>
-          <p:nvPr/>
-        </p:nvSpPr>
-        <p:spPr>
-          <a:xfrm>
-            <a:off x="932688" y="594360"/>
-            <a:ext cx="2926080" cy="219456"/>
+            <a:endParaRPr lang="en-US" sz="2200" dirty="0"/>
+          </a:p>
+        </p:txBody>
+      </p:sp>
+      <p:sp>
+        <p:nvSpPr>
+          <p:cNvPr id="5" name="Text 1"/>
+          <p:cNvSpPr txBox="1"/>
+          <p:nvPr/>
+        </p:nvSpPr>
+        <p:spPr>
+          <a:xfrm>
+            <a:off x="1170432" y="731520"/>
+            <a:ext cx="3291840" cy="274320"/>
           </a:xfrm>
           <a:prstGeom prst="rect">
             <a:avLst/>
@@ -1447,7 +1432,7 @@
               <a:buNone/>
             </a:pPr>
             <a:r>
-              <a:rPr lang="en-US" sz="750" b="1" spc="200" kern="0" dirty="0">
+              <a:rPr lang="en-US" sz="1100" b="1" spc="200" kern="0" dirty="0">
                 <a:solidFill>
                   <a:srgbClr val="5B5F66"/>
                 </a:solidFill>
@@ -1457,13 +1442,13 @@
               </a:rPr>
               <a:t>INDUSTRIES, INC.</a:t>
             </a:r>
-            <a:endParaRPr lang="en-US" sz="750" dirty="0"/>
-          </a:p>
-        </p:txBody>
-      </p:sp>
-      <p:sp>
-        <p:nvSpPr>
-          <p:cNvPr id="6" name="Shape 3"/>
+            <a:endParaRPr lang="en-US" sz="1100" dirty="0"/>
+          </a:p>
+        </p:txBody>
+      </p:sp>
+      <p:sp>
+        <p:nvSpPr>
+          <p:cNvPr id="6" name="Shape 2"/>
           <p:cNvSpPr/>
           <p:nvPr/>
         </p:nvSpPr>
@@ -1483,7 +1468,7 @@
       </p:sp>
       <p:sp>
         <p:nvSpPr>
-          <p:cNvPr id="7" name="Shape 4"/>
+          <p:cNvPr id="7" name="Shape 3"/>
           <p:cNvSpPr/>
           <p:nvPr/>
         </p:nvSpPr>
@@ -1503,7 +1488,7 @@
       </p:sp>
       <p:sp>
         <p:nvSpPr>
-          <p:cNvPr id="8" name="Text 5"/>
+          <p:cNvPr id="8" name="Text 4"/>
           <p:cNvSpPr txBox="1"/>
           <p:nvPr/>
         </p:nvSpPr>
@@ -1542,7 +1527,7 @@
       </p:sp>
       <p:sp>
         <p:nvSpPr>
-          <p:cNvPr id="9" name="Text 6"/>
+          <p:cNvPr id="9" name="Text 5"/>
           <p:cNvSpPr txBox="1"/>
           <p:nvPr/>
         </p:nvSpPr>
@@ -1604,7 +1589,7 @@
       </p:sp>
       <p:sp>
         <p:nvSpPr>
-          <p:cNvPr id="10" name="Text 7"/>
+          <p:cNvPr id="10" name="Text 6"/>
           <p:cNvSpPr txBox="1"/>
           <p:nvPr/>
         </p:nvSpPr>
@@ -1643,7 +1628,7 @@
       </p:sp>
       <p:sp>
         <p:nvSpPr>
-          <p:cNvPr id="11" name="Text 8"/>
+          <p:cNvPr id="11" name="Text 7"/>
           <p:cNvSpPr txBox="1"/>
           <p:nvPr/>
         </p:nvSpPr>
@@ -1682,7 +1667,7 @@
       </p:sp>
       <p:sp>
         <p:nvSpPr>
-          <p:cNvPr id="12" name="Text 9"/>
+          <p:cNvPr id="12" name="Text 8"/>
           <p:cNvSpPr txBox="1"/>
           <p:nvPr/>
         </p:nvSpPr>
@@ -1724,7 +1709,7 @@
       </p:sp>
       <p:sp>
         <p:nvSpPr>
-          <p:cNvPr id="13" name="Shape 10"/>
+          <p:cNvPr id="13" name="Shape 9"/>
           <p:cNvSpPr/>
           <p:nvPr/>
         </p:nvSpPr>
@@ -1747,7 +1732,7 @@
       </p:sp>
       <p:sp>
         <p:nvSpPr>
-          <p:cNvPr id="14" name="Text 11"/>
+          <p:cNvPr id="14" name="Text 10"/>
           <p:cNvSpPr txBox="1"/>
           <p:nvPr/>
         </p:nvSpPr>
@@ -1786,7 +1771,7 @@
       </p:sp>
       <p:sp>
         <p:nvSpPr>
-          <p:cNvPr id="15" name="Text 12"/>
+          <p:cNvPr id="15" name="Text 11"/>
           <p:cNvSpPr txBox="1"/>
           <p:nvPr/>
         </p:nvSpPr>
@@ -1868,7 +1853,7 @@
       </p:sp>
       <p:sp>
         <p:nvSpPr>
-          <p:cNvPr id="16" name="Text 13"/>
+          <p:cNvPr id="16" name="Text 12"/>
           <p:cNvSpPr txBox="1"/>
           <p:nvPr/>
         </p:nvSpPr>
@@ -1907,7 +1892,7 @@
       </p:sp>
       <p:sp>
         <p:nvSpPr>
-          <p:cNvPr id="17" name="Text 14"/>
+          <p:cNvPr id="17" name="Text 13"/>
           <p:cNvSpPr txBox="1"/>
           <p:nvPr/>
         </p:nvSpPr>
@@ -2197,55 +2182,40 @@
         <p:spPr>
           <a:xfrm>
             <a:off x="457200" y="365760"/>
-            <a:ext cx="1828800" cy="384048"/>
+            <a:ext cx="2743200" cy="576072"/>
           </a:xfrm>
           <a:prstGeom prst="rect">
             <a:avLst/>
           </a:prstGeom>
         </p:spPr>
       </p:pic>
-      <p:sp>
-        <p:nvSpPr>
-          <p:cNvPr id="9" name="Text 6"/>
-          <p:cNvSpPr txBox="1"/>
-          <p:nvPr/>
-        </p:nvSpPr>
-        <p:spPr>
-          <a:xfrm>
-            <a:off x="6949440" y="0"/>
-            <a:ext cx="5486400" cy="6858000"/>
-          </a:xfrm>
-          <a:prstGeom prst="rect">
-            <a:avLst/>
-          </a:prstGeom>
-          <a:noFill/>
-          <a:ln/>
-        </p:spPr>
-        <p:txBody>
-          <a:bodyPr wrap="square" lIns="0" tIns="0" rIns="0" bIns="0" rtlCol="0" anchor="t"/>
-          <a:lstStyle/>
-          <a:p>
-            <a:pPr algn="r" indent="0" marL="0">
-              <a:buNone/>
-            </a:pPr>
-            <a:r>
-              <a:rPr lang="en-US" sz="36000" b="1" dirty="0">
-                <a:solidFill>
-                  <a:srgbClr val="EBEBE9"/>
-                </a:solidFill>
-                <a:latin typeface="Cambria" pitchFamily="34" charset="0"/>
-                <a:ea typeface="Cambria" pitchFamily="34" charset="-122"/>
-                <a:cs typeface="Cambria" pitchFamily="34" charset="-120"/>
-              </a:rPr>
-              <a:t>02</a:t>
-            </a:r>
-            <a:endParaRPr lang="en-US" sz="36000" dirty="0"/>
-          </a:p>
-        </p:txBody>
-      </p:sp>
-      <p:sp>
-        <p:nvSpPr>
-          <p:cNvPr id="10" name="Text 7"/>
+      <p:pic>
+        <p:nvPicPr>
+          <p:cNvPr id="9" name="Image 1" descr="/home/user/valletta-design-system/assets/logo/valletta-mark-ghost.png">    </p:cNvPr>
+          <p:cNvPicPr>
+            <a:picLocks noChangeAspect="1"/>
+          </p:cNvPicPr>
+          <p:nvPr/>
+        </p:nvPicPr>
+        <p:blipFill>
+          <a:blip r:embed="rId2"/>
+          <a:stretch>
+            <a:fillRect/>
+          </a:stretch>
+        </p:blipFill>
+        <p:spPr>
+          <a:xfrm>
+            <a:off x="7891272" y="502920"/>
+            <a:ext cx="5486400" cy="5839260"/>
+          </a:xfrm>
+          <a:prstGeom prst="rect">
+            <a:avLst/>
+          </a:prstGeom>
+        </p:spPr>
+      </p:pic>
+      <p:sp>
+        <p:nvSpPr>
+          <p:cNvPr id="10" name="Text 6"/>
           <p:cNvSpPr txBox="1"/>
           <p:nvPr/>
         </p:nvSpPr>
@@ -2284,7 +2254,7 @@
       </p:sp>
       <p:sp>
         <p:nvSpPr>
-          <p:cNvPr id="11" name="Text 8"/>
+          <p:cNvPr id="11" name="Text 7"/>
           <p:cNvSpPr txBox="1"/>
           <p:nvPr/>
         </p:nvSpPr>
@@ -2326,7 +2296,7 @@
       </p:sp>
       <p:sp>
         <p:nvSpPr>
-          <p:cNvPr id="12" name="Text 9"/>
+          <p:cNvPr id="12" name="Text 8"/>
           <p:cNvSpPr txBox="1"/>
           <p:nvPr/>
         </p:nvSpPr>
@@ -2368,7 +2338,7 @@
       </p:sp>
       <p:sp>
         <p:nvSpPr>
-          <p:cNvPr id="13" name="Text 10"/>
+          <p:cNvPr id="13" name="Text 9"/>
           <p:cNvSpPr txBox="1"/>
           <p:nvPr/>
         </p:nvSpPr>
@@ -2407,7 +2377,7 @@
       </p:sp>
       <p:sp>
         <p:nvSpPr>
-          <p:cNvPr id="14" name="Text 11"/>
+          <p:cNvPr id="14" name="Text 10"/>
           <p:cNvSpPr txBox="1"/>
           <p:nvPr/>
         </p:nvSpPr>
@@ -2446,7 +2416,7 @@
       </p:sp>
       <p:sp>
         <p:nvSpPr>
-          <p:cNvPr id="15" name="Text 12"/>
+          <p:cNvPr id="15" name="Text 11"/>
           <p:cNvSpPr txBox="1"/>
           <p:nvPr/>
         </p:nvSpPr>
@@ -2488,7 +2458,7 @@
       </p:sp>
       <p:sp>
         <p:nvSpPr>
-          <p:cNvPr id="16" name="Shape 13"/>
+          <p:cNvPr id="16" name="Shape 12"/>
           <p:cNvSpPr/>
           <p:nvPr/>
         </p:nvSpPr>
@@ -2511,7 +2481,7 @@
       </p:sp>
       <p:sp>
         <p:nvSpPr>
-          <p:cNvPr id="17" name="Text 14"/>
+          <p:cNvPr id="17" name="Text 13"/>
           <p:cNvSpPr txBox="1"/>
           <p:nvPr/>
         </p:nvSpPr>
@@ -2550,7 +2520,7 @@
       </p:sp>
       <p:sp>
         <p:nvSpPr>
-          <p:cNvPr id="18" name="Text 15"/>
+          <p:cNvPr id="18" name="Text 14"/>
           <p:cNvSpPr txBox="1"/>
           <p:nvPr/>
         </p:nvSpPr>
@@ -2589,7 +2559,7 @@
       </p:sp>
       <p:sp>
         <p:nvSpPr>
-          <p:cNvPr id="19" name="Text 16"/>
+          <p:cNvPr id="19" name="Text 15"/>
           <p:cNvSpPr txBox="1"/>
           <p:nvPr/>
         </p:nvSpPr>
@@ -2631,7 +2601,7 @@
       </p:sp>
       <p:sp>
         <p:nvSpPr>
-          <p:cNvPr id="20" name="Shape 17"/>
+          <p:cNvPr id="20" name="Shape 16"/>
           <p:cNvSpPr/>
           <p:nvPr/>
         </p:nvSpPr>
@@ -2654,7 +2624,7 @@
       </p:sp>
       <p:sp>
         <p:nvSpPr>
-          <p:cNvPr id="21" name="Text 18"/>
+          <p:cNvPr id="21" name="Text 17"/>
           <p:cNvSpPr txBox="1"/>
           <p:nvPr/>
         </p:nvSpPr>
@@ -2693,7 +2663,7 @@
       </p:sp>
       <p:sp>
         <p:nvSpPr>
-          <p:cNvPr id="22" name="Text 19"/>
+          <p:cNvPr id="22" name="Text 18"/>
           <p:cNvSpPr txBox="1"/>
           <p:nvPr/>
         </p:nvSpPr>
@@ -2732,7 +2702,7 @@
       </p:sp>
       <p:sp>
         <p:nvSpPr>
-          <p:cNvPr id="23" name="Text 20"/>
+          <p:cNvPr id="23" name="Text 19"/>
           <p:cNvSpPr txBox="1"/>
           <p:nvPr/>
         </p:nvSpPr>
@@ -2774,7 +2744,7 @@
       </p:sp>
       <p:sp>
         <p:nvSpPr>
-          <p:cNvPr id="24" name="Text 21"/>
+          <p:cNvPr id="24" name="Text 20"/>
           <p:cNvSpPr txBox="1"/>
           <p:nvPr/>
         </p:nvSpPr>
@@ -2813,7 +2783,7 @@
       </p:sp>
       <p:sp>
         <p:nvSpPr>
-          <p:cNvPr id="25" name="Shape 22"/>
+          <p:cNvPr id="25" name="Shape 21"/>
           <p:cNvSpPr/>
           <p:nvPr/>
         </p:nvSpPr>
@@ -2837,7 +2807,7 @@
       </p:sp>
       <p:sp>
         <p:nvSpPr>
-          <p:cNvPr id="26" name="Text 23"/>
+          <p:cNvPr id="26" name="Text 22"/>
           <p:cNvSpPr txBox="1"/>
           <p:nvPr/>
         </p:nvSpPr>
@@ -2890,7 +2860,7 @@
       </p:sp>
       <p:sp>
         <p:nvSpPr>
-          <p:cNvPr id="27" name="Text 24"/>
+          <p:cNvPr id="27" name="Text 23"/>
           <p:cNvSpPr txBox="1"/>
           <p:nvPr/>
         </p:nvSpPr>
@@ -2959,48 +2929,9 @@
           <a:chExt cx="0" cy="0"/>
         </a:xfrm>
       </p:grpSpPr>
-      <p:sp>
-        <p:nvSpPr>
-          <p:cNvPr id="2" name="Text 0"/>
-          <p:cNvSpPr txBox="1"/>
-          <p:nvPr/>
-        </p:nvSpPr>
-        <p:spPr>
-          <a:xfrm>
-            <a:off x="6949440" y="0"/>
-            <a:ext cx="5486400" cy="6858000"/>
-          </a:xfrm>
-          <a:prstGeom prst="rect">
-            <a:avLst/>
-          </a:prstGeom>
-          <a:noFill/>
-          <a:ln/>
-        </p:spPr>
-        <p:txBody>
-          <a:bodyPr wrap="square" lIns="0" tIns="0" rIns="0" bIns="0" rtlCol="0" anchor="t"/>
-          <a:lstStyle/>
-          <a:p>
-            <a:pPr algn="r" indent="0" marL="0">
-              <a:buNone/>
-            </a:pPr>
-            <a:r>
-              <a:rPr lang="en-US" sz="36000" b="1" dirty="0">
-                <a:solidFill>
-                  <a:srgbClr val="EBEBE9"/>
-                </a:solidFill>
-                <a:latin typeface="Cambria" pitchFamily="34" charset="0"/>
-                <a:ea typeface="Cambria" pitchFamily="34" charset="-122"/>
-                <a:cs typeface="Cambria" pitchFamily="34" charset="-120"/>
-              </a:rPr>
-              <a:t>03</a:t>
-            </a:r>
-            <a:endParaRPr lang="en-US" sz="36000" dirty="0"/>
-          </a:p>
-        </p:txBody>
-      </p:sp>
       <p:pic>
         <p:nvPicPr>
-          <p:cNvPr id="3" name="Image 0" descr="/home/user/valletta-design-system/assets/logo/valletta-lockup.png">    </p:cNvPr>
+          <p:cNvPr id="2" name="Image 0" descr="/home/user/valletta-design-system/assets/logo/valletta-mark-ghost.png">    </p:cNvPr>
           <p:cNvPicPr>
             <a:picLocks noChangeAspect="1"/>
           </p:cNvPicPr>
@@ -3014,8 +2945,32 @@
         </p:blipFill>
         <p:spPr>
           <a:xfrm>
+            <a:off x="7891272" y="502920"/>
+            <a:ext cx="5486400" cy="5839260"/>
+          </a:xfrm>
+          <a:prstGeom prst="rect">
+            <a:avLst/>
+          </a:prstGeom>
+        </p:spPr>
+      </p:pic>
+      <p:pic>
+        <p:nvPicPr>
+          <p:cNvPr id="3" name="Image 1" descr="/home/user/valletta-design-system/assets/logo/valletta-lockup.png">    </p:cNvPr>
+          <p:cNvPicPr>
+            <a:picLocks noChangeAspect="1"/>
+          </p:cNvPicPr>
+          <p:nvPr/>
+        </p:nvPicPr>
+        <p:blipFill>
+          <a:blip r:embed="rId2"/>
+          <a:stretch>
+            <a:fillRect/>
+          </a:stretch>
+        </p:blipFill>
+        <p:spPr>
+          <a:xfrm>
             <a:off x="457200" y="365760"/>
-            <a:ext cx="1828800" cy="384048"/>
+            <a:ext cx="2743200" cy="576072"/>
           </a:xfrm>
           <a:prstGeom prst="rect">
             <a:avLst/>
@@ -3024,13 +2979,13 @@
       </p:pic>
       <p:sp>
         <p:nvSpPr>
-          <p:cNvPr id="4" name="Text 1"/>
-          <p:cNvSpPr txBox="1"/>
-          <p:nvPr/>
-        </p:nvSpPr>
-        <p:spPr>
-          <a:xfrm>
-            <a:off x="457200" y="777240"/>
+          <p:cNvPr id="4" name="Text 0"/>
+          <p:cNvSpPr txBox="1"/>
+          <p:nvPr/>
+        </p:nvSpPr>
+        <p:spPr>
+          <a:xfrm>
+            <a:off x="457200" y="1005840"/>
             <a:ext cx="9144000" cy="320040"/>
           </a:xfrm>
           <a:prstGeom prst="rect">
@@ -3063,13 +3018,13 @@
       </p:sp>
       <p:sp>
         <p:nvSpPr>
-          <p:cNvPr id="5" name="Text 2"/>
-          <p:cNvSpPr txBox="1"/>
-          <p:nvPr/>
-        </p:nvSpPr>
-        <p:spPr>
-          <a:xfrm>
-            <a:off x="457200" y="1097280"/>
+          <p:cNvPr id="5" name="Text 1"/>
+          <p:cNvSpPr txBox="1"/>
+          <p:nvPr/>
+        </p:nvSpPr>
+        <p:spPr>
+          <a:xfrm>
+            <a:off x="457200" y="1325880"/>
             <a:ext cx="11274552" cy="685800"/>
           </a:xfrm>
           <a:prstGeom prst="rect">
@@ -3115,8 +3070,8 @@
           </p:nvPr>
         </p:nvGraphicFramePr>
         <p:xfrm>
-          <a:off x="457200" y="1920240"/>
-          <a:ext cx="7040880" cy="4251960"/>
+          <a:off x="457200" y="2148840"/>
+          <a:ext cx="7040880" cy="4023360"/>
         </p:xfrm>
         <a:graphic>
           <a:graphicData uri="http://schemas.openxmlformats.org/drawingml/2006/table">
@@ -3126,7 +3081,7 @@
                 <a:gridCol w="3246120"/>
                 <a:gridCol w="3794760"/>
               </a:tblGrid>
-              <a:tr h="708660">
+              <a:tr h="670560">
                 <a:tc>
                   <a:txBody>
                     <a:bodyPr/>
@@ -3250,7 +3205,7 @@
                   </a:tcPr>
                 </a:tc>
               </a:tr>
-              <a:tr h="708660">
+              <a:tr h="670560">
                 <a:tc>
                   <a:txBody>
                     <a:bodyPr/>
@@ -3374,7 +3329,7 @@
                   </a:tcPr>
                 </a:tc>
               </a:tr>
-              <a:tr h="708660">
+              <a:tr h="670560">
                 <a:tc>
                   <a:txBody>
                     <a:bodyPr/>
@@ -3498,7 +3453,7 @@
                   </a:tcPr>
                 </a:tc>
               </a:tr>
-              <a:tr h="708660">
+              <a:tr h="670560">
                 <a:tc>
                   <a:txBody>
                     <a:bodyPr/>
@@ -3622,7 +3577,7 @@
                   </a:tcPr>
                 </a:tc>
               </a:tr>
-              <a:tr h="708660">
+              <a:tr h="670560">
                 <a:tc>
                   <a:txBody>
                     <a:bodyPr/>
@@ -3746,7 +3701,7 @@
                   </a:tcPr>
                 </a:tc>
               </a:tr>
-              <a:tr h="708660">
+              <a:tr h="670560">
                 <a:tc>
                   <a:txBody>
                     <a:bodyPr/>
@@ -3876,14 +3831,14 @@
       </p:graphicFrame>
       <p:sp>
         <p:nvSpPr>
-          <p:cNvPr id="7" name="Shape 3"/>
+          <p:cNvPr id="7" name="Shape 2"/>
           <p:cNvSpPr/>
           <p:nvPr/>
         </p:nvSpPr>
         <p:spPr>
           <a:xfrm>
-            <a:off x="7726680" y="1920240"/>
-            <a:ext cx="4005072" cy="4251960"/>
+            <a:off x="7726680" y="2148840"/>
+            <a:ext cx="4005072" cy="4023360"/>
           </a:xfrm>
           <a:prstGeom prst="rect">
             <a:avLst/>
@@ -3908,13 +3863,13 @@
       </p:sp>
       <p:sp>
         <p:nvSpPr>
-          <p:cNvPr id="8" name="Shape 4"/>
+          <p:cNvPr id="8" name="Shape 3"/>
           <p:cNvSpPr/>
           <p:nvPr/>
         </p:nvSpPr>
         <p:spPr>
           <a:xfrm>
-            <a:off x="7726680" y="1920240"/>
+            <a:off x="7726680" y="2148840"/>
             <a:ext cx="365760" cy="36576"/>
           </a:xfrm>
           <a:prstGeom prst="rect">
@@ -3928,13 +3883,13 @@
       </p:sp>
       <p:sp>
         <p:nvSpPr>
-          <p:cNvPr id="9" name="Shape 5"/>
+          <p:cNvPr id="9" name="Shape 4"/>
           <p:cNvSpPr/>
           <p:nvPr/>
         </p:nvSpPr>
         <p:spPr>
           <a:xfrm>
-            <a:off x="7726680" y="1920240"/>
+            <a:off x="7726680" y="2148840"/>
             <a:ext cx="36576" cy="365760"/>
           </a:xfrm>
           <a:prstGeom prst="rect">
@@ -3948,13 +3903,13 @@
       </p:sp>
       <p:sp>
         <p:nvSpPr>
-          <p:cNvPr id="10" name="Shape 6"/>
+          <p:cNvPr id="10" name="Shape 5"/>
           <p:cNvSpPr/>
           <p:nvPr/>
         </p:nvSpPr>
         <p:spPr>
           <a:xfrm>
-            <a:off x="7726680" y="1920240"/>
+            <a:off x="7726680" y="2148840"/>
             <a:ext cx="4005072" cy="384048"/>
           </a:xfrm>
           <a:prstGeom prst="rect">
@@ -3968,13 +3923,13 @@
       </p:sp>
       <p:sp>
         <p:nvSpPr>
-          <p:cNvPr id="11" name="Text 7"/>
-          <p:cNvSpPr txBox="1"/>
-          <p:nvPr/>
-        </p:nvSpPr>
-        <p:spPr>
-          <a:xfrm>
-            <a:off x="7863840" y="1920240"/>
+          <p:cNvPr id="11" name="Text 6"/>
+          <p:cNvSpPr txBox="1"/>
+          <p:nvPr/>
+        </p:nvSpPr>
+        <p:spPr>
+          <a:xfrm>
+            <a:off x="7863840" y="2148840"/>
             <a:ext cx="3730752" cy="384048"/>
           </a:xfrm>
           <a:prstGeom prst="rect">
@@ -4007,14 +3962,14 @@
       </p:sp>
       <p:sp>
         <p:nvSpPr>
-          <p:cNvPr id="12" name="Text 8"/>
-          <p:cNvSpPr txBox="1"/>
-          <p:nvPr/>
-        </p:nvSpPr>
-        <p:spPr>
-          <a:xfrm>
-            <a:off x="7955280" y="2468880"/>
-            <a:ext cx="3547872" cy="3063240"/>
+          <p:cNvPr id="12" name="Text 7"/>
+          <p:cNvSpPr txBox="1"/>
+          <p:nvPr/>
+        </p:nvSpPr>
+        <p:spPr>
+          <a:xfrm>
+            <a:off x="7955280" y="2697480"/>
+            <a:ext cx="3547872" cy="2834640"/>
           </a:xfrm>
           <a:prstGeom prst="rect">
             <a:avLst/>
@@ -4229,7 +4184,7 @@
       </p:sp>
       <p:sp>
         <p:nvSpPr>
-          <p:cNvPr id="13" name="Text 9"/>
+          <p:cNvPr id="13" name="Text 8"/>
           <p:cNvSpPr txBox="1"/>
           <p:nvPr/>
         </p:nvSpPr>
@@ -4271,7 +4226,7 @@
       </p:sp>
       <p:sp>
         <p:nvSpPr>
-          <p:cNvPr id="14" name="Shape 10"/>
+          <p:cNvPr id="14" name="Shape 9"/>
           <p:cNvSpPr/>
           <p:nvPr/>
         </p:nvSpPr>
@@ -4295,7 +4250,7 @@
       </p:sp>
       <p:sp>
         <p:nvSpPr>
-          <p:cNvPr id="15" name="Text 11"/>
+          <p:cNvPr id="15" name="Text 10"/>
           <p:cNvSpPr txBox="1"/>
           <p:nvPr/>
         </p:nvSpPr>
@@ -4348,7 +4303,7 @@
       </p:sp>
       <p:sp>
         <p:nvSpPr>
-          <p:cNvPr id="16" name="Text 12"/>
+          <p:cNvPr id="16" name="Text 11"/>
           <p:cNvSpPr txBox="1"/>
           <p:nvPr/>
         </p:nvSpPr>
@@ -4417,48 +4372,9 @@
           <a:chExt cx="0" cy="0"/>
         </a:xfrm>
       </p:grpSpPr>
-      <p:sp>
-        <p:nvSpPr>
-          <p:cNvPr id="2" name="Text 0"/>
-          <p:cNvSpPr txBox="1"/>
-          <p:nvPr/>
-        </p:nvSpPr>
-        <p:spPr>
-          <a:xfrm>
-            <a:off x="6949440" y="0"/>
-            <a:ext cx="5486400" cy="6858000"/>
-          </a:xfrm>
-          <a:prstGeom prst="rect">
-            <a:avLst/>
-          </a:prstGeom>
-          <a:noFill/>
-          <a:ln/>
-        </p:spPr>
-        <p:txBody>
-          <a:bodyPr wrap="square" lIns="0" tIns="0" rIns="0" bIns="0" rtlCol="0" anchor="t"/>
-          <a:lstStyle/>
-          <a:p>
-            <a:pPr algn="r" indent="0" marL="0">
-              <a:buNone/>
-            </a:pPr>
-            <a:r>
-              <a:rPr lang="en-US" sz="36000" b="1" dirty="0">
-                <a:solidFill>
-                  <a:srgbClr val="141414"/>
-                </a:solidFill>
-                <a:latin typeface="Cambria" pitchFamily="34" charset="0"/>
-                <a:ea typeface="Cambria" pitchFamily="34" charset="-122"/>
-                <a:cs typeface="Cambria" pitchFamily="34" charset="-120"/>
-              </a:rPr>
-              <a:t>04</a:t>
-            </a:r>
-            <a:endParaRPr lang="en-US" sz="36000" dirty="0"/>
-          </a:p>
-        </p:txBody>
-      </p:sp>
       <p:pic>
         <p:nvPicPr>
-          <p:cNvPr id="3" name="Image 0" descr="/home/user/valletta-design-system/assets/logo/valletta-mark.png">    </p:cNvPr>
+          <p:cNvPr id="2" name="Image 0" descr="/home/user/valletta-design-system/assets/logo/valletta-mark-ghost.png">    </p:cNvPr>
           <p:cNvPicPr>
             <a:picLocks noChangeAspect="1"/>
           </p:cNvPicPr>
@@ -4472,8 +4388,32 @@
         </p:blipFill>
         <p:spPr>
           <a:xfrm>
+            <a:off x="7891272" y="502920"/>
+            <a:ext cx="5486400" cy="5839260"/>
+          </a:xfrm>
+          <a:prstGeom prst="rect">
+            <a:avLst/>
+          </a:prstGeom>
+        </p:spPr>
+      </p:pic>
+      <p:pic>
+        <p:nvPicPr>
+          <p:cNvPr id="3" name="Image 1" descr="/home/user/valletta-design-system/assets/logo/valletta-mark.png">    </p:cNvPr>
+          <p:cNvPicPr>
+            <a:picLocks noChangeAspect="1"/>
+          </p:cNvPicPr>
+          <p:nvPr/>
+        </p:nvPicPr>
+        <p:blipFill>
+          <a:blip r:embed="rId2"/>
+          <a:stretch>
+            <a:fillRect/>
+          </a:stretch>
+        </p:blipFill>
+        <p:spPr>
+          <a:xfrm>
             <a:off x="457200" y="365760"/>
-            <a:ext cx="365760" cy="389284"/>
+            <a:ext cx="548640" cy="583926"/>
           </a:xfrm>
           <a:prstGeom prst="rect">
             <a:avLst/>
@@ -4482,14 +4422,14 @@
       </p:pic>
       <p:sp>
         <p:nvSpPr>
-          <p:cNvPr id="4" name="Text 1"/>
-          <p:cNvSpPr txBox="1"/>
-          <p:nvPr/>
-        </p:nvSpPr>
-        <p:spPr>
-          <a:xfrm>
-            <a:off x="932688" y="329184"/>
-            <a:ext cx="2926080" cy="274320"/>
+          <p:cNvPr id="4" name="Text 0"/>
+          <p:cNvSpPr txBox="1"/>
+          <p:nvPr/>
+        </p:nvSpPr>
+        <p:spPr>
+          <a:xfrm>
+            <a:off x="1170432" y="347472"/>
+            <a:ext cx="3291840" cy="402336"/>
           </a:xfrm>
           <a:prstGeom prst="rect">
             <a:avLst/>
@@ -4505,7 +4445,7 @@
               <a:buNone/>
             </a:pPr>
             <a:r>
-              <a:rPr lang="en-US" sz="1500" spc="200" kern="0" dirty="0">
+              <a:rPr lang="en-US" sz="2200" spc="200" kern="0" dirty="0">
                 <a:solidFill>
                   <a:srgbClr val="FFFFFF"/>
                 </a:solidFill>
@@ -4515,20 +4455,20 @@
               </a:rPr>
               <a:t>VALLETTA</a:t>
             </a:r>
-            <a:endParaRPr lang="en-US" sz="1500" dirty="0"/>
-          </a:p>
-        </p:txBody>
-      </p:sp>
-      <p:sp>
-        <p:nvSpPr>
-          <p:cNvPr id="5" name="Text 2"/>
-          <p:cNvSpPr txBox="1"/>
-          <p:nvPr/>
-        </p:nvSpPr>
-        <p:spPr>
-          <a:xfrm>
-            <a:off x="932688" y="594360"/>
-            <a:ext cx="2926080" cy="219456"/>
+            <a:endParaRPr lang="en-US" sz="2200" dirty="0"/>
+          </a:p>
+        </p:txBody>
+      </p:sp>
+      <p:sp>
+        <p:nvSpPr>
+          <p:cNvPr id="5" name="Text 1"/>
+          <p:cNvSpPr txBox="1"/>
+          <p:nvPr/>
+        </p:nvSpPr>
+        <p:spPr>
+          <a:xfrm>
+            <a:off x="1170432" y="731520"/>
+            <a:ext cx="3291840" cy="274320"/>
           </a:xfrm>
           <a:prstGeom prst="rect">
             <a:avLst/>
@@ -4544,7 +4484,7 @@
               <a:buNone/>
             </a:pPr>
             <a:r>
-              <a:rPr lang="en-US" sz="750" b="1" spc="200" kern="0" dirty="0">
+              <a:rPr lang="en-US" sz="1100" b="1" spc="200" kern="0" dirty="0">
                 <a:solidFill>
                   <a:srgbClr val="5B5F66"/>
                 </a:solidFill>
@@ -4554,19 +4494,19 @@
               </a:rPr>
               <a:t>INDUSTRIES, INC.</a:t>
             </a:r>
-            <a:endParaRPr lang="en-US" sz="750" dirty="0"/>
-          </a:p>
-        </p:txBody>
-      </p:sp>
-      <p:sp>
-        <p:nvSpPr>
-          <p:cNvPr id="6" name="Text 3"/>
-          <p:cNvSpPr txBox="1"/>
-          <p:nvPr/>
-        </p:nvSpPr>
-        <p:spPr>
-          <a:xfrm>
-            <a:off x="457200" y="777240"/>
+            <a:endParaRPr lang="en-US" sz="1100" dirty="0"/>
+          </a:p>
+        </p:txBody>
+      </p:sp>
+      <p:sp>
+        <p:nvSpPr>
+          <p:cNvPr id="6" name="Text 2"/>
+          <p:cNvSpPr txBox="1"/>
+          <p:nvPr/>
+        </p:nvSpPr>
+        <p:spPr>
+          <a:xfrm>
+            <a:off x="457200" y="1005840"/>
             <a:ext cx="9144000" cy="320040"/>
           </a:xfrm>
           <a:prstGeom prst="rect">
@@ -4599,13 +4539,13 @@
       </p:sp>
       <p:sp>
         <p:nvSpPr>
-          <p:cNvPr id="7" name="Text 4"/>
-          <p:cNvSpPr txBox="1"/>
-          <p:nvPr/>
-        </p:nvSpPr>
-        <p:spPr>
-          <a:xfrm>
-            <a:off x="457200" y="1097280"/>
+          <p:cNvPr id="7" name="Text 3"/>
+          <p:cNvSpPr txBox="1"/>
+          <p:nvPr/>
+        </p:nvSpPr>
+        <p:spPr>
+          <a:xfrm>
+            <a:off x="457200" y="1325880"/>
             <a:ext cx="11274552" cy="914400"/>
           </a:xfrm>
           <a:prstGeom prst="rect">
@@ -4641,13 +4581,13 @@
       </p:sp>
       <p:sp>
         <p:nvSpPr>
-          <p:cNvPr id="8" name="Text 5"/>
-          <p:cNvSpPr txBox="1"/>
-          <p:nvPr/>
-        </p:nvSpPr>
-        <p:spPr>
-          <a:xfrm>
-            <a:off x="457200" y="1956816"/>
+          <p:cNvPr id="8" name="Text 4"/>
+          <p:cNvSpPr txBox="1"/>
+          <p:nvPr/>
+        </p:nvSpPr>
+        <p:spPr>
+          <a:xfrm>
+            <a:off x="457200" y="2231136"/>
             <a:ext cx="4937760" cy="274320"/>
           </a:xfrm>
           <a:prstGeom prst="rect">
@@ -4680,14 +4620,14 @@
       </p:sp>
       <p:sp>
         <p:nvSpPr>
-          <p:cNvPr id="9" name="Shape 6"/>
+          <p:cNvPr id="9" name="Shape 5"/>
           <p:cNvSpPr/>
           <p:nvPr/>
         </p:nvSpPr>
         <p:spPr>
           <a:xfrm>
-            <a:off x="457200" y="2286000"/>
-            <a:ext cx="4937760" cy="3063240"/>
+            <a:off x="457200" y="2560320"/>
+            <a:ext cx="4937760" cy="2788920"/>
           </a:xfrm>
           <a:prstGeom prst="rect">
             <a:avLst/>
@@ -4700,14 +4640,14 @@
       </p:sp>
       <p:sp>
         <p:nvSpPr>
-          <p:cNvPr id="10" name="Shape 7"/>
+          <p:cNvPr id="10" name="Shape 6"/>
           <p:cNvSpPr/>
           <p:nvPr/>
         </p:nvSpPr>
         <p:spPr>
           <a:xfrm>
-            <a:off x="457200" y="2286000"/>
-            <a:ext cx="490118" cy="41148"/>
+            <a:off x="457200" y="2560320"/>
+            <a:ext cx="446227" cy="41148"/>
           </a:xfrm>
           <a:prstGeom prst="rect">
             <a:avLst/>
@@ -4720,14 +4660,14 @@
       </p:sp>
       <p:sp>
         <p:nvSpPr>
-          <p:cNvPr id="11" name="Shape 8"/>
+          <p:cNvPr id="11" name="Shape 7"/>
           <p:cNvSpPr/>
           <p:nvPr/>
         </p:nvSpPr>
         <p:spPr>
           <a:xfrm>
-            <a:off x="457200" y="2286000"/>
-            <a:ext cx="41148" cy="490118"/>
+            <a:off x="457200" y="2560320"/>
+            <a:ext cx="41148" cy="446227"/>
           </a:xfrm>
           <a:prstGeom prst="rect">
             <a:avLst/>
@@ -4740,13 +4680,13 @@
       </p:sp>
       <p:sp>
         <p:nvSpPr>
-          <p:cNvPr id="12" name="Shape 9"/>
+          <p:cNvPr id="12" name="Shape 8"/>
           <p:cNvSpPr/>
           <p:nvPr/>
         </p:nvSpPr>
         <p:spPr>
           <a:xfrm>
-            <a:off x="2148840" y="3040380"/>
+            <a:off x="2148840" y="3177540"/>
             <a:ext cx="274320" cy="274320"/>
           </a:xfrm>
           <a:prstGeom prst="ellipse">
@@ -4760,13 +4700,13 @@
       </p:sp>
       <p:sp>
         <p:nvSpPr>
-          <p:cNvPr id="13" name="Shape 10"/>
+          <p:cNvPr id="13" name="Shape 9"/>
           <p:cNvSpPr/>
           <p:nvPr/>
         </p:nvSpPr>
         <p:spPr>
           <a:xfrm>
-            <a:off x="2240280" y="3360420"/>
+            <a:off x="2240280" y="3497580"/>
             <a:ext cx="1005840" cy="685800"/>
           </a:xfrm>
           <a:prstGeom prst="triangle">
@@ -4780,13 +4720,13 @@
       </p:sp>
       <p:sp>
         <p:nvSpPr>
-          <p:cNvPr id="14" name="Shape 11"/>
+          <p:cNvPr id="14" name="Shape 10"/>
           <p:cNvSpPr/>
           <p:nvPr/>
         </p:nvSpPr>
         <p:spPr>
           <a:xfrm>
-            <a:off x="2788920" y="3177540"/>
+            <a:off x="2788920" y="3314700"/>
             <a:ext cx="868680" cy="868680"/>
           </a:xfrm>
           <a:prstGeom prst="triangle">
@@ -4800,13 +4740,13 @@
       </p:sp>
       <p:sp>
         <p:nvSpPr>
-          <p:cNvPr id="15" name="Text 12"/>
-          <p:cNvSpPr txBox="1"/>
-          <p:nvPr/>
-        </p:nvSpPr>
-        <p:spPr>
-          <a:xfrm>
-            <a:off x="640080" y="4000500"/>
+          <p:cNvPr id="15" name="Text 11"/>
+          <p:cNvSpPr txBox="1"/>
+          <p:nvPr/>
+        </p:nvSpPr>
+        <p:spPr>
+          <a:xfrm>
+            <a:off x="640080" y="4137660"/>
             <a:ext cx="4572000" cy="274320"/>
           </a:xfrm>
           <a:prstGeom prst="rect">
@@ -4839,13 +4779,13 @@
       </p:sp>
       <p:sp>
         <p:nvSpPr>
-          <p:cNvPr id="16" name="Text 13"/>
-          <p:cNvSpPr txBox="1"/>
-          <p:nvPr/>
-        </p:nvSpPr>
-        <p:spPr>
-          <a:xfrm>
-            <a:off x="731520" y="4293108"/>
+          <p:cNvPr id="16" name="Text 12"/>
+          <p:cNvSpPr txBox="1"/>
+          <p:nvPr/>
+        </p:nvSpPr>
+        <p:spPr>
+          <a:xfrm>
+            <a:off x="731520" y="4430268"/>
             <a:ext cx="4389120" cy="548640"/>
           </a:xfrm>
           <a:prstGeom prst="rect">
@@ -4881,13 +4821,13 @@
       </p:sp>
       <p:sp>
         <p:nvSpPr>
-          <p:cNvPr id="17" name="Text 14"/>
-          <p:cNvSpPr txBox="1"/>
-          <p:nvPr/>
-        </p:nvSpPr>
-        <p:spPr>
-          <a:xfrm>
-            <a:off x="5559552" y="1956816"/>
+          <p:cNvPr id="17" name="Text 13"/>
+          <p:cNvSpPr txBox="1"/>
+          <p:nvPr/>
+        </p:nvSpPr>
+        <p:spPr>
+          <a:xfrm>
+            <a:off x="5559552" y="2231136"/>
             <a:ext cx="3003804" cy="274320"/>
           </a:xfrm>
           <a:prstGeom prst="rect">
@@ -4920,14 +4860,14 @@
       </p:sp>
       <p:sp>
         <p:nvSpPr>
-          <p:cNvPr id="18" name="Shape 15"/>
+          <p:cNvPr id="18" name="Shape 14"/>
           <p:cNvSpPr/>
           <p:nvPr/>
         </p:nvSpPr>
         <p:spPr>
           <a:xfrm>
-            <a:off x="5559552" y="2286000"/>
-            <a:ext cx="3003804" cy="3063240"/>
+            <a:off x="5559552" y="2560320"/>
+            <a:ext cx="3003804" cy="2788920"/>
           </a:xfrm>
           <a:prstGeom prst="rect">
             <a:avLst/>
@@ -4940,14 +4880,14 @@
       </p:sp>
       <p:sp>
         <p:nvSpPr>
-          <p:cNvPr id="19" name="Shape 16"/>
+          <p:cNvPr id="19" name="Shape 15"/>
           <p:cNvSpPr/>
           <p:nvPr/>
         </p:nvSpPr>
         <p:spPr>
           <a:xfrm>
-            <a:off x="5559552" y="2286000"/>
-            <a:ext cx="480609" cy="41148"/>
+            <a:off x="5559552" y="2560320"/>
+            <a:ext cx="446227" cy="41148"/>
           </a:xfrm>
           <a:prstGeom prst="rect">
             <a:avLst/>
@@ -4960,14 +4900,14 @@
       </p:sp>
       <p:sp>
         <p:nvSpPr>
-          <p:cNvPr id="20" name="Shape 17"/>
+          <p:cNvPr id="20" name="Shape 16"/>
           <p:cNvSpPr/>
           <p:nvPr/>
         </p:nvSpPr>
         <p:spPr>
           <a:xfrm>
-            <a:off x="5559552" y="2286000"/>
-            <a:ext cx="41148" cy="480609"/>
+            <a:off x="5559552" y="2560320"/>
+            <a:ext cx="41148" cy="446227"/>
           </a:xfrm>
           <a:prstGeom prst="rect">
             <a:avLst/>
@@ -4980,13 +4920,13 @@
       </p:sp>
       <p:sp>
         <p:nvSpPr>
-          <p:cNvPr id="21" name="Shape 18"/>
+          <p:cNvPr id="21" name="Shape 17"/>
           <p:cNvSpPr/>
           <p:nvPr/>
         </p:nvSpPr>
         <p:spPr>
           <a:xfrm>
-            <a:off x="6284214" y="3040380"/>
+            <a:off x="6284214" y="3177540"/>
             <a:ext cx="274320" cy="274320"/>
           </a:xfrm>
           <a:prstGeom prst="ellipse">
@@ -5000,13 +4940,13 @@
       </p:sp>
       <p:sp>
         <p:nvSpPr>
-          <p:cNvPr id="22" name="Shape 19"/>
+          <p:cNvPr id="22" name="Shape 18"/>
           <p:cNvSpPr/>
           <p:nvPr/>
         </p:nvSpPr>
         <p:spPr>
           <a:xfrm>
-            <a:off x="6375654" y="3360420"/>
+            <a:off x="6375654" y="3497580"/>
             <a:ext cx="1005840" cy="685800"/>
           </a:xfrm>
           <a:prstGeom prst="triangle">
@@ -5020,13 +4960,13 @@
       </p:sp>
       <p:sp>
         <p:nvSpPr>
-          <p:cNvPr id="23" name="Shape 20"/>
+          <p:cNvPr id="23" name="Shape 19"/>
           <p:cNvSpPr/>
           <p:nvPr/>
         </p:nvSpPr>
         <p:spPr>
           <a:xfrm>
-            <a:off x="6924294" y="3177540"/>
+            <a:off x="6924294" y="3314700"/>
             <a:ext cx="868680" cy="868680"/>
           </a:xfrm>
           <a:prstGeom prst="triangle">
@@ -5040,13 +4980,13 @@
       </p:sp>
       <p:sp>
         <p:nvSpPr>
-          <p:cNvPr id="24" name="Text 21"/>
-          <p:cNvSpPr txBox="1"/>
-          <p:nvPr/>
-        </p:nvSpPr>
-        <p:spPr>
-          <a:xfrm>
-            <a:off x="5742432" y="4000500"/>
+          <p:cNvPr id="24" name="Text 20"/>
+          <p:cNvSpPr txBox="1"/>
+          <p:nvPr/>
+        </p:nvSpPr>
+        <p:spPr>
+          <a:xfrm>
+            <a:off x="5742432" y="4137660"/>
             <a:ext cx="2638044" cy="274320"/>
           </a:xfrm>
           <a:prstGeom prst="rect">
@@ -5079,13 +5019,13 @@
       </p:sp>
       <p:sp>
         <p:nvSpPr>
-          <p:cNvPr id="25" name="Text 22"/>
-          <p:cNvSpPr txBox="1"/>
-          <p:nvPr/>
-        </p:nvSpPr>
-        <p:spPr>
-          <a:xfrm>
-            <a:off x="5833872" y="4293108"/>
+          <p:cNvPr id="25" name="Text 21"/>
+          <p:cNvSpPr txBox="1"/>
+          <p:nvPr/>
+        </p:nvSpPr>
+        <p:spPr>
+          <a:xfrm>
+            <a:off x="5833872" y="4430268"/>
             <a:ext cx="2455164" cy="548640"/>
           </a:xfrm>
           <a:prstGeom prst="rect">
@@ -5121,13 +5061,13 @@
       </p:sp>
       <p:sp>
         <p:nvSpPr>
-          <p:cNvPr id="26" name="Text 23"/>
-          <p:cNvSpPr txBox="1"/>
-          <p:nvPr/>
-        </p:nvSpPr>
-        <p:spPr>
-          <a:xfrm>
-            <a:off x="8727948" y="1956816"/>
+          <p:cNvPr id="26" name="Text 22"/>
+          <p:cNvSpPr txBox="1"/>
+          <p:nvPr/>
+        </p:nvSpPr>
+        <p:spPr>
+          <a:xfrm>
+            <a:off x="8727948" y="2231136"/>
             <a:ext cx="3003804" cy="274320"/>
           </a:xfrm>
           <a:prstGeom prst="rect">
@@ -5160,14 +5100,14 @@
       </p:sp>
       <p:sp>
         <p:nvSpPr>
-          <p:cNvPr id="27" name="Shape 24"/>
+          <p:cNvPr id="27" name="Shape 23"/>
           <p:cNvSpPr/>
           <p:nvPr/>
         </p:nvSpPr>
         <p:spPr>
           <a:xfrm>
-            <a:off x="8727948" y="2286000"/>
-            <a:ext cx="3003804" cy="3063240"/>
+            <a:off x="8727948" y="2560320"/>
+            <a:ext cx="3003804" cy="2788920"/>
           </a:xfrm>
           <a:prstGeom prst="rect">
             <a:avLst/>
@@ -5180,14 +5120,14 @@
       </p:sp>
       <p:sp>
         <p:nvSpPr>
-          <p:cNvPr id="28" name="Shape 25"/>
+          <p:cNvPr id="28" name="Shape 24"/>
           <p:cNvSpPr/>
           <p:nvPr/>
         </p:nvSpPr>
         <p:spPr>
           <a:xfrm>
-            <a:off x="8727948" y="2286000"/>
-            <a:ext cx="480609" cy="41148"/>
+            <a:off x="8727948" y="2560320"/>
+            <a:ext cx="446227" cy="41148"/>
           </a:xfrm>
           <a:prstGeom prst="rect">
             <a:avLst/>
@@ -5200,14 +5140,14 @@
       </p:sp>
       <p:sp>
         <p:nvSpPr>
-          <p:cNvPr id="29" name="Shape 26"/>
+          <p:cNvPr id="29" name="Shape 25"/>
           <p:cNvSpPr/>
           <p:nvPr/>
         </p:nvSpPr>
         <p:spPr>
           <a:xfrm>
-            <a:off x="8727948" y="2286000"/>
-            <a:ext cx="41148" cy="480609"/>
+            <a:off x="8727948" y="2560320"/>
+            <a:ext cx="41148" cy="446227"/>
           </a:xfrm>
           <a:prstGeom prst="rect">
             <a:avLst/>
@@ -5220,13 +5160,13 @@
       </p:sp>
       <p:sp>
         <p:nvSpPr>
-          <p:cNvPr id="30" name="Shape 27"/>
+          <p:cNvPr id="30" name="Shape 26"/>
           <p:cNvSpPr/>
           <p:nvPr/>
         </p:nvSpPr>
         <p:spPr>
           <a:xfrm>
-            <a:off x="9452610" y="3040380"/>
+            <a:off x="9452610" y="3177540"/>
             <a:ext cx="274320" cy="274320"/>
           </a:xfrm>
           <a:prstGeom prst="ellipse">
@@ -5240,13 +5180,13 @@
       </p:sp>
       <p:sp>
         <p:nvSpPr>
-          <p:cNvPr id="31" name="Shape 28"/>
+          <p:cNvPr id="31" name="Shape 27"/>
           <p:cNvSpPr/>
           <p:nvPr/>
         </p:nvSpPr>
         <p:spPr>
           <a:xfrm>
-            <a:off x="9544050" y="3360420"/>
+            <a:off x="9544050" y="3497580"/>
             <a:ext cx="1005840" cy="685800"/>
           </a:xfrm>
           <a:prstGeom prst="triangle">
@@ -5260,13 +5200,13 @@
       </p:sp>
       <p:sp>
         <p:nvSpPr>
-          <p:cNvPr id="32" name="Shape 29"/>
+          <p:cNvPr id="32" name="Shape 28"/>
           <p:cNvSpPr/>
           <p:nvPr/>
         </p:nvSpPr>
         <p:spPr>
           <a:xfrm>
-            <a:off x="10092690" y="3177540"/>
+            <a:off x="10092690" y="3314700"/>
             <a:ext cx="868680" cy="868680"/>
           </a:xfrm>
           <a:prstGeom prst="triangle">
@@ -5280,13 +5220,13 @@
       </p:sp>
       <p:sp>
         <p:nvSpPr>
-          <p:cNvPr id="33" name="Text 30"/>
-          <p:cNvSpPr txBox="1"/>
-          <p:nvPr/>
-        </p:nvSpPr>
-        <p:spPr>
-          <a:xfrm>
-            <a:off x="8910828" y="4000500"/>
+          <p:cNvPr id="33" name="Text 29"/>
+          <p:cNvSpPr txBox="1"/>
+          <p:nvPr/>
+        </p:nvSpPr>
+        <p:spPr>
+          <a:xfrm>
+            <a:off x="8910828" y="4137660"/>
             <a:ext cx="2638044" cy="274320"/>
           </a:xfrm>
           <a:prstGeom prst="rect">
@@ -5319,13 +5259,13 @@
       </p:sp>
       <p:sp>
         <p:nvSpPr>
-          <p:cNvPr id="34" name="Text 31"/>
-          <p:cNvSpPr txBox="1"/>
-          <p:nvPr/>
-        </p:nvSpPr>
-        <p:spPr>
-          <a:xfrm>
-            <a:off x="9002268" y="4293108"/>
+          <p:cNvPr id="34" name="Text 30"/>
+          <p:cNvSpPr txBox="1"/>
+          <p:nvPr/>
+        </p:nvSpPr>
+        <p:spPr>
+          <a:xfrm>
+            <a:off x="9002268" y="4430268"/>
             <a:ext cx="2455164" cy="548640"/>
           </a:xfrm>
           <a:prstGeom prst="rect">
@@ -5361,7 +5301,7 @@
       </p:sp>
       <p:sp>
         <p:nvSpPr>
-          <p:cNvPr id="35" name="Text 32"/>
+          <p:cNvPr id="35" name="Text 31"/>
           <p:cNvSpPr txBox="1"/>
           <p:nvPr/>
         </p:nvSpPr>
@@ -5400,7 +5340,7 @@
       </p:sp>
       <p:sp>
         <p:nvSpPr>
-          <p:cNvPr id="36" name="Shape 33"/>
+          <p:cNvPr id="36" name="Shape 32"/>
           <p:cNvSpPr/>
           <p:nvPr/>
         </p:nvSpPr>
@@ -5424,7 +5364,7 @@
       </p:sp>
       <p:sp>
         <p:nvSpPr>
-          <p:cNvPr id="37" name="Text 34"/>
+          <p:cNvPr id="37" name="Text 33"/>
           <p:cNvSpPr txBox="1"/>
           <p:nvPr/>
         </p:nvSpPr>
@@ -5477,7 +5417,7 @@
       </p:sp>
       <p:sp>
         <p:nvSpPr>
-          <p:cNvPr id="38" name="Text 35"/>
+          <p:cNvPr id="38" name="Text 34"/>
           <p:cNvSpPr txBox="1"/>
           <p:nvPr/>
         </p:nvSpPr>
@@ -5546,48 +5486,9 @@
           <a:chExt cx="0" cy="0"/>
         </a:xfrm>
       </p:grpSpPr>
-      <p:sp>
-        <p:nvSpPr>
-          <p:cNvPr id="2" name="Text 0"/>
-          <p:cNvSpPr txBox="1"/>
-          <p:nvPr/>
-        </p:nvSpPr>
-        <p:spPr>
-          <a:xfrm>
-            <a:off x="6949440" y="0"/>
-            <a:ext cx="5486400" cy="6858000"/>
-          </a:xfrm>
-          <a:prstGeom prst="rect">
-            <a:avLst/>
-          </a:prstGeom>
-          <a:noFill/>
-          <a:ln/>
-        </p:spPr>
-        <p:txBody>
-          <a:bodyPr wrap="square" lIns="0" tIns="0" rIns="0" bIns="0" rtlCol="0" anchor="t"/>
-          <a:lstStyle/>
-          <a:p>
-            <a:pPr algn="r" indent="0" marL="0">
-              <a:buNone/>
-            </a:pPr>
-            <a:r>
-              <a:rPr lang="en-US" sz="36000" b="1" dirty="0">
-                <a:solidFill>
-                  <a:srgbClr val="141414"/>
-                </a:solidFill>
-                <a:latin typeface="Cambria" pitchFamily="34" charset="0"/>
-                <a:ea typeface="Cambria" pitchFamily="34" charset="-122"/>
-                <a:cs typeface="Cambria" pitchFamily="34" charset="-120"/>
-              </a:rPr>
-              <a:t>05</a:t>
-            </a:r>
-            <a:endParaRPr lang="en-US" sz="36000" dirty="0"/>
-          </a:p>
-        </p:txBody>
-      </p:sp>
       <p:pic>
         <p:nvPicPr>
-          <p:cNvPr id="3" name="Image 0" descr="/home/user/valletta-design-system/assets/logo/valletta-mark.png">    </p:cNvPr>
+          <p:cNvPr id="2" name="Image 0" descr="/home/user/valletta-design-system/assets/logo/valletta-mark-ghost.png">    </p:cNvPr>
           <p:cNvPicPr>
             <a:picLocks noChangeAspect="1"/>
           </p:cNvPicPr>
@@ -5601,212 +5502,17 @@
         </p:blipFill>
         <p:spPr>
           <a:xfrm>
-            <a:off x="457200" y="365760"/>
-            <a:ext cx="365760" cy="389284"/>
+            <a:off x="7891272" y="502920"/>
+            <a:ext cx="5486400" cy="5839260"/>
           </a:xfrm>
           <a:prstGeom prst="rect">
             <a:avLst/>
           </a:prstGeom>
         </p:spPr>
       </p:pic>
-      <p:sp>
-        <p:nvSpPr>
-          <p:cNvPr id="4" name="Text 1"/>
-          <p:cNvSpPr txBox="1"/>
-          <p:nvPr/>
-        </p:nvSpPr>
-        <p:spPr>
-          <a:xfrm>
-            <a:off x="932688" y="329184"/>
-            <a:ext cx="2926080" cy="274320"/>
-          </a:xfrm>
-          <a:prstGeom prst="rect">
-            <a:avLst/>
-          </a:prstGeom>
-          <a:noFill/>
-          <a:ln/>
-        </p:spPr>
-        <p:txBody>
-          <a:bodyPr wrap="square" lIns="0" tIns="0" rIns="0" bIns="0" rtlCol="0" anchor="ctr"/>
-          <a:lstStyle/>
-          <a:p>
-            <a:pPr indent="0" marL="0">
-              <a:buNone/>
-            </a:pPr>
-            <a:r>
-              <a:rPr lang="en-US" sz="1500" spc="200" kern="0" dirty="0">
-                <a:solidFill>
-                  <a:srgbClr val="FFFFFF"/>
-                </a:solidFill>
-                <a:latin typeface="Cambria" pitchFamily="34" charset="0"/>
-                <a:ea typeface="Cambria" pitchFamily="34" charset="-122"/>
-                <a:cs typeface="Cambria" pitchFamily="34" charset="-120"/>
-              </a:rPr>
-              <a:t>VALLETTA</a:t>
-            </a:r>
-            <a:endParaRPr lang="en-US" sz="1500" dirty="0"/>
-          </a:p>
-        </p:txBody>
-      </p:sp>
-      <p:sp>
-        <p:nvSpPr>
-          <p:cNvPr id="5" name="Text 2"/>
-          <p:cNvSpPr txBox="1"/>
-          <p:nvPr/>
-        </p:nvSpPr>
-        <p:spPr>
-          <a:xfrm>
-            <a:off x="932688" y="594360"/>
-            <a:ext cx="2926080" cy="219456"/>
-          </a:xfrm>
-          <a:prstGeom prst="rect">
-            <a:avLst/>
-          </a:prstGeom>
-          <a:noFill/>
-          <a:ln/>
-        </p:spPr>
-        <p:txBody>
-          <a:bodyPr wrap="square" lIns="0" tIns="0" rIns="0" bIns="0" rtlCol="0" anchor="ctr"/>
-          <a:lstStyle/>
-          <a:p>
-            <a:pPr indent="0" marL="0">
-              <a:buNone/>
-            </a:pPr>
-            <a:r>
-              <a:rPr lang="en-US" sz="750" b="1" spc="200" kern="0" dirty="0">
-                <a:solidFill>
-                  <a:srgbClr val="5B5F66"/>
-                </a:solidFill>
-                <a:latin typeface="Arial" pitchFamily="34" charset="0"/>
-                <a:ea typeface="Arial" pitchFamily="34" charset="-122"/>
-                <a:cs typeface="Arial" pitchFamily="34" charset="-120"/>
-              </a:rPr>
-              <a:t>INDUSTRIES, INC.</a:t>
-            </a:r>
-            <a:endParaRPr lang="en-US" sz="750" dirty="0"/>
-          </a:p>
-        </p:txBody>
-      </p:sp>
-      <p:sp>
-        <p:nvSpPr>
-          <p:cNvPr id="6" name="Text 3"/>
-          <p:cNvSpPr txBox="1"/>
-          <p:nvPr/>
-        </p:nvSpPr>
-        <p:spPr>
-          <a:xfrm>
-            <a:off x="457200" y="777240"/>
-            <a:ext cx="7315200" cy="320040"/>
-          </a:xfrm>
-          <a:prstGeom prst="rect">
-            <a:avLst/>
-          </a:prstGeom>
-          <a:noFill/>
-          <a:ln/>
-        </p:spPr>
-        <p:txBody>
-          <a:bodyPr wrap="square" lIns="0" tIns="0" rIns="0" bIns="0" rtlCol="0" anchor="ctr"/>
-          <a:lstStyle/>
-          <a:p>
-            <a:pPr algn="l" indent="0" marL="0">
-              <a:buNone/>
-            </a:pPr>
-            <a:r>
-              <a:rPr lang="en-US" sz="1100" b="1" spc="150" kern="0" dirty="0">
-                <a:solidFill>
-                  <a:srgbClr val="FF002B"/>
-                </a:solidFill>
-                <a:latin typeface="Arial" pitchFamily="34" charset="0"/>
-                <a:ea typeface="Arial" pitchFamily="34" charset="-122"/>
-                <a:cs typeface="Arial" pitchFamily="34" charset="-120"/>
-              </a:rPr>
-              <a:t>FEATURED CAPABILITY</a:t>
-            </a:r>
-            <a:endParaRPr lang="en-US" sz="1100" dirty="0"/>
-          </a:p>
-        </p:txBody>
-      </p:sp>
-      <p:sp>
-        <p:nvSpPr>
-          <p:cNvPr id="7" name="Text 4"/>
-          <p:cNvSpPr txBox="1"/>
-          <p:nvPr/>
-        </p:nvSpPr>
-        <p:spPr>
-          <a:xfrm>
-            <a:off x="457200" y="1097280"/>
-            <a:ext cx="7315200" cy="731520"/>
-          </a:xfrm>
-          <a:prstGeom prst="rect">
-            <a:avLst/>
-          </a:prstGeom>
-          <a:noFill/>
-          <a:ln/>
-        </p:spPr>
-        <p:txBody>
-          <a:bodyPr wrap="square" lIns="0" tIns="0" rIns="0" bIns="0" rtlCol="0" anchor="ctr"/>
-          <a:lstStyle/>
-          <a:p>
-            <a:pPr indent="0" marL="0">
-              <a:buNone/>
-            </a:pPr>
-            <a:r>
-              <a:rPr lang="en-US" sz="3800" b="1" dirty="0">
-                <a:solidFill>
-                  <a:srgbClr val="FFFFFF"/>
-                </a:solidFill>
-                <a:latin typeface="Cambria" pitchFamily="34" charset="0"/>
-                <a:ea typeface="Cambria" pitchFamily="34" charset="-122"/>
-                <a:cs typeface="Cambria" pitchFamily="34" charset="-120"/>
-              </a:rPr>
-              <a:t>MISSION PROTECT</a:t>
-            </a:r>
-            <a:endParaRPr lang="en-US" sz="3800" dirty="0"/>
-          </a:p>
-        </p:txBody>
-      </p:sp>
-      <p:sp>
-        <p:nvSpPr>
-          <p:cNvPr id="8" name="Text 5"/>
-          <p:cNvSpPr txBox="1"/>
-          <p:nvPr/>
-        </p:nvSpPr>
-        <p:spPr>
-          <a:xfrm>
-            <a:off x="457200" y="1828800"/>
-            <a:ext cx="7315200" cy="320040"/>
-          </a:xfrm>
-          <a:prstGeom prst="rect">
-            <a:avLst/>
-          </a:prstGeom>
-          <a:noFill/>
-          <a:ln/>
-        </p:spPr>
-        <p:txBody>
-          <a:bodyPr wrap="square" lIns="0" tIns="0" rIns="0" bIns="0" rtlCol="0" anchor="ctr"/>
-          <a:lstStyle/>
-          <a:p>
-            <a:pPr indent="0" marL="0">
-              <a:buNone/>
-            </a:pPr>
-            <a:r>
-              <a:rPr lang="en-US" sz="1300" b="1" spc="150" kern="0" dirty="0">
-                <a:solidFill>
-                  <a:srgbClr val="FF002B"/>
-                </a:solidFill>
-                <a:latin typeface="Arial" pitchFamily="34" charset="0"/>
-                <a:ea typeface="Arial" pitchFamily="34" charset="-122"/>
-                <a:cs typeface="Arial" pitchFamily="34" charset="-120"/>
-              </a:rPr>
-              <a:t>A DOI-OWNED DIGITAL TRAINING PATHWAY</a:t>
-            </a:r>
-            <a:endParaRPr lang="en-US" sz="1300" dirty="0"/>
-          </a:p>
-        </p:txBody>
-      </p:sp>
       <p:pic>
         <p:nvPicPr>
-          <p:cNvPr id="9" name="Image 1" descr="/home/user/valletta-design-system/assets/mission-protect/mp-course-detail.png">    </p:cNvPr>
+          <p:cNvPr id="3" name="Image 1" descr="/home/user/valletta-design-system/assets/logo/valletta-mark.png">    </p:cNvPr>
           <p:cNvPicPr>
             <a:picLocks noChangeAspect="1"/>
           </p:cNvPicPr>
@@ -5820,6 +5526,225 @@
         </p:blipFill>
         <p:spPr>
           <a:xfrm>
+            <a:off x="457200" y="365760"/>
+            <a:ext cx="548640" cy="583926"/>
+          </a:xfrm>
+          <a:prstGeom prst="rect">
+            <a:avLst/>
+          </a:prstGeom>
+        </p:spPr>
+      </p:pic>
+      <p:sp>
+        <p:nvSpPr>
+          <p:cNvPr id="4" name="Text 0"/>
+          <p:cNvSpPr txBox="1"/>
+          <p:nvPr/>
+        </p:nvSpPr>
+        <p:spPr>
+          <a:xfrm>
+            <a:off x="1170432" y="347472"/>
+            <a:ext cx="3291840" cy="402336"/>
+          </a:xfrm>
+          <a:prstGeom prst="rect">
+            <a:avLst/>
+          </a:prstGeom>
+          <a:noFill/>
+          <a:ln/>
+        </p:spPr>
+        <p:txBody>
+          <a:bodyPr wrap="square" lIns="0" tIns="0" rIns="0" bIns="0" rtlCol="0" anchor="ctr"/>
+          <a:lstStyle/>
+          <a:p>
+            <a:pPr indent="0" marL="0">
+              <a:buNone/>
+            </a:pPr>
+            <a:r>
+              <a:rPr lang="en-US" sz="2200" spc="200" kern="0" dirty="0">
+                <a:solidFill>
+                  <a:srgbClr val="FFFFFF"/>
+                </a:solidFill>
+                <a:latin typeface="Cambria" pitchFamily="34" charset="0"/>
+                <a:ea typeface="Cambria" pitchFamily="34" charset="-122"/>
+                <a:cs typeface="Cambria" pitchFamily="34" charset="-120"/>
+              </a:rPr>
+              <a:t>VALLETTA</a:t>
+            </a:r>
+            <a:endParaRPr lang="en-US" sz="2200" dirty="0"/>
+          </a:p>
+        </p:txBody>
+      </p:sp>
+      <p:sp>
+        <p:nvSpPr>
+          <p:cNvPr id="5" name="Text 1"/>
+          <p:cNvSpPr txBox="1"/>
+          <p:nvPr/>
+        </p:nvSpPr>
+        <p:spPr>
+          <a:xfrm>
+            <a:off x="1170432" y="731520"/>
+            <a:ext cx="3291840" cy="274320"/>
+          </a:xfrm>
+          <a:prstGeom prst="rect">
+            <a:avLst/>
+          </a:prstGeom>
+          <a:noFill/>
+          <a:ln/>
+        </p:spPr>
+        <p:txBody>
+          <a:bodyPr wrap="square" lIns="0" tIns="0" rIns="0" bIns="0" rtlCol="0" anchor="ctr"/>
+          <a:lstStyle/>
+          <a:p>
+            <a:pPr indent="0" marL="0">
+              <a:buNone/>
+            </a:pPr>
+            <a:r>
+              <a:rPr lang="en-US" sz="1100" b="1" spc="200" kern="0" dirty="0">
+                <a:solidFill>
+                  <a:srgbClr val="5B5F66"/>
+                </a:solidFill>
+                <a:latin typeface="Arial" pitchFamily="34" charset="0"/>
+                <a:ea typeface="Arial" pitchFamily="34" charset="-122"/>
+                <a:cs typeface="Arial" pitchFamily="34" charset="-120"/>
+              </a:rPr>
+              <a:t>INDUSTRIES, INC.</a:t>
+            </a:r>
+            <a:endParaRPr lang="en-US" sz="1100" dirty="0"/>
+          </a:p>
+        </p:txBody>
+      </p:sp>
+      <p:sp>
+        <p:nvSpPr>
+          <p:cNvPr id="6" name="Text 2"/>
+          <p:cNvSpPr txBox="1"/>
+          <p:nvPr/>
+        </p:nvSpPr>
+        <p:spPr>
+          <a:xfrm>
+            <a:off x="457200" y="1005840"/>
+            <a:ext cx="7315200" cy="320040"/>
+          </a:xfrm>
+          <a:prstGeom prst="rect">
+            <a:avLst/>
+          </a:prstGeom>
+          <a:noFill/>
+          <a:ln/>
+        </p:spPr>
+        <p:txBody>
+          <a:bodyPr wrap="square" lIns="0" tIns="0" rIns="0" bIns="0" rtlCol="0" anchor="ctr"/>
+          <a:lstStyle/>
+          <a:p>
+            <a:pPr algn="l" indent="0" marL="0">
+              <a:buNone/>
+            </a:pPr>
+            <a:r>
+              <a:rPr lang="en-US" sz="1100" b="1" spc="150" kern="0" dirty="0">
+                <a:solidFill>
+                  <a:srgbClr val="FF002B"/>
+                </a:solidFill>
+                <a:latin typeface="Arial" pitchFamily="34" charset="0"/>
+                <a:ea typeface="Arial" pitchFamily="34" charset="-122"/>
+                <a:cs typeface="Arial" pitchFamily="34" charset="-120"/>
+              </a:rPr>
+              <a:t>FEATURED CAPABILITY</a:t>
+            </a:r>
+            <a:endParaRPr lang="en-US" sz="1100" dirty="0"/>
+          </a:p>
+        </p:txBody>
+      </p:sp>
+      <p:sp>
+        <p:nvSpPr>
+          <p:cNvPr id="7" name="Text 3"/>
+          <p:cNvSpPr txBox="1"/>
+          <p:nvPr/>
+        </p:nvSpPr>
+        <p:spPr>
+          <a:xfrm>
+            <a:off x="457200" y="1325880"/>
+            <a:ext cx="7315200" cy="731520"/>
+          </a:xfrm>
+          <a:prstGeom prst="rect">
+            <a:avLst/>
+          </a:prstGeom>
+          <a:noFill/>
+          <a:ln/>
+        </p:spPr>
+        <p:txBody>
+          <a:bodyPr wrap="square" lIns="0" tIns="0" rIns="0" bIns="0" rtlCol="0" anchor="ctr"/>
+          <a:lstStyle/>
+          <a:p>
+            <a:pPr indent="0" marL="0">
+              <a:buNone/>
+            </a:pPr>
+            <a:r>
+              <a:rPr lang="en-US" sz="3800" b="1" dirty="0">
+                <a:solidFill>
+                  <a:srgbClr val="FFFFFF"/>
+                </a:solidFill>
+                <a:latin typeface="Cambria" pitchFamily="34" charset="0"/>
+                <a:ea typeface="Cambria" pitchFamily="34" charset="-122"/>
+                <a:cs typeface="Cambria" pitchFamily="34" charset="-120"/>
+              </a:rPr>
+              <a:t>MISSION PROTECT</a:t>
+            </a:r>
+            <a:endParaRPr lang="en-US" sz="3800" dirty="0"/>
+          </a:p>
+        </p:txBody>
+      </p:sp>
+      <p:sp>
+        <p:nvSpPr>
+          <p:cNvPr id="8" name="Text 4"/>
+          <p:cNvSpPr txBox="1"/>
+          <p:nvPr/>
+        </p:nvSpPr>
+        <p:spPr>
+          <a:xfrm>
+            <a:off x="457200" y="2057400"/>
+            <a:ext cx="7315200" cy="320040"/>
+          </a:xfrm>
+          <a:prstGeom prst="rect">
+            <a:avLst/>
+          </a:prstGeom>
+          <a:noFill/>
+          <a:ln/>
+        </p:spPr>
+        <p:txBody>
+          <a:bodyPr wrap="square" lIns="0" tIns="0" rIns="0" bIns="0" rtlCol="0" anchor="ctr"/>
+          <a:lstStyle/>
+          <a:p>
+            <a:pPr indent="0" marL="0">
+              <a:buNone/>
+            </a:pPr>
+            <a:r>
+              <a:rPr lang="en-US" sz="1300" b="1" spc="150" kern="0" dirty="0">
+                <a:solidFill>
+                  <a:srgbClr val="FF002B"/>
+                </a:solidFill>
+                <a:latin typeface="Arial" pitchFamily="34" charset="0"/>
+                <a:ea typeface="Arial" pitchFamily="34" charset="-122"/>
+                <a:cs typeface="Arial" pitchFamily="34" charset="-120"/>
+              </a:rPr>
+              <a:t>A DOI-OWNED DIGITAL TRAINING PATHWAY</a:t>
+            </a:r>
+            <a:endParaRPr lang="en-US" sz="1300" dirty="0"/>
+          </a:p>
+        </p:txBody>
+      </p:sp>
+      <p:pic>
+        <p:nvPicPr>
+          <p:cNvPr id="9" name="Image 2" descr="/home/user/valletta-design-system/assets/mission-protect/mp-course-detail.png">    </p:cNvPr>
+          <p:cNvPicPr>
+            <a:picLocks noChangeAspect="1"/>
+          </p:cNvPicPr>
+          <p:nvPr/>
+        </p:nvPicPr>
+        <p:blipFill>
+          <a:blip r:embed="rId3"/>
+          <a:stretch>
+            <a:fillRect/>
+          </a:stretch>
+        </p:blipFill>
+        <p:spPr>
+          <a:xfrm>
             <a:off x="7909560" y="1234440"/>
             <a:ext cx="2862072" cy="4930330"/>
           </a:xfrm>
@@ -5837,7 +5762,7 @@
       </p:pic>
       <p:sp>
         <p:nvSpPr>
-          <p:cNvPr id="10" name="Shape 6"/>
+          <p:cNvPr id="10" name="Shape 5"/>
           <p:cNvSpPr/>
           <p:nvPr/>
         </p:nvSpPr>
@@ -5859,7 +5784,7 @@
       </p:sp>
       <p:sp>
         <p:nvSpPr>
-          <p:cNvPr id="11" name="Text 7"/>
+          <p:cNvPr id="11" name="Text 6"/>
           <p:cNvSpPr txBox="1"/>
           <p:nvPr/>
         </p:nvSpPr>
@@ -5898,7 +5823,7 @@
       </p:sp>
       <p:sp>
         <p:nvSpPr>
-          <p:cNvPr id="12" name="Shape 8"/>
+          <p:cNvPr id="12" name="Shape 7"/>
           <p:cNvSpPr/>
           <p:nvPr/>
         </p:nvSpPr>
@@ -5923,7 +5848,7 @@
       </p:sp>
       <p:sp>
         <p:nvSpPr>
-          <p:cNvPr id="13" name="Text 9"/>
+          <p:cNvPr id="13" name="Text 8"/>
           <p:cNvSpPr txBox="1"/>
           <p:nvPr/>
         </p:nvSpPr>
@@ -5962,14 +5887,14 @@
       </p:sp>
       <p:sp>
         <p:nvSpPr>
-          <p:cNvPr id="14" name="Text 10"/>
-          <p:cNvSpPr txBox="1"/>
-          <p:nvPr/>
-        </p:nvSpPr>
-        <p:spPr>
-          <a:xfrm>
-            <a:off x="457200" y="2331720"/>
-            <a:ext cx="5120640" cy="1417320"/>
+          <p:cNvPr id="14" name="Text 9"/>
+          <p:cNvSpPr txBox="1"/>
+          <p:nvPr/>
+        </p:nvSpPr>
+        <p:spPr>
+          <a:xfrm>
+            <a:off x="457200" y="2606040"/>
+            <a:ext cx="5120640" cy="1371600"/>
           </a:xfrm>
           <a:prstGeom prst="rect">
             <a:avLst/>
@@ -6004,13 +5929,13 @@
       </p:sp>
       <p:sp>
         <p:nvSpPr>
-          <p:cNvPr id="15" name="Text 11"/>
-          <p:cNvSpPr txBox="1"/>
-          <p:nvPr/>
-        </p:nvSpPr>
-        <p:spPr>
-          <a:xfrm>
-            <a:off x="457200" y="4069080"/>
+          <p:cNvPr id="15" name="Text 10"/>
+          <p:cNvSpPr txBox="1"/>
+          <p:nvPr/>
+        </p:nvSpPr>
+        <p:spPr>
+          <a:xfrm>
+            <a:off x="457200" y="4206240"/>
             <a:ext cx="5120640" cy="274320"/>
           </a:xfrm>
           <a:prstGeom prst="rect">
@@ -6043,13 +5968,13 @@
       </p:sp>
       <p:sp>
         <p:nvSpPr>
-          <p:cNvPr id="16" name="Text 12"/>
-          <p:cNvSpPr txBox="1"/>
-          <p:nvPr/>
-        </p:nvSpPr>
-        <p:spPr>
-          <a:xfrm>
-            <a:off x="457200" y="4325112"/>
+          <p:cNvPr id="16" name="Text 11"/>
+          <p:cNvSpPr txBox="1"/>
+          <p:nvPr/>
+        </p:nvSpPr>
+        <p:spPr>
+          <a:xfrm>
+            <a:off x="457200" y="4462272"/>
             <a:ext cx="5120640" cy="411480"/>
           </a:xfrm>
           <a:prstGeom prst="rect">
@@ -6085,13 +6010,13 @@
       </p:sp>
       <p:sp>
         <p:nvSpPr>
-          <p:cNvPr id="17" name="Shape 13"/>
+          <p:cNvPr id="17" name="Shape 12"/>
           <p:cNvSpPr/>
           <p:nvPr/>
         </p:nvSpPr>
         <p:spPr>
           <a:xfrm>
-            <a:off x="457200" y="4782312"/>
+            <a:off x="457200" y="4846320"/>
             <a:ext cx="5120640" cy="0"/>
           </a:xfrm>
           <a:prstGeom prst="line">
@@ -6108,13 +6033,13 @@
       </p:sp>
       <p:sp>
         <p:nvSpPr>
-          <p:cNvPr id="18" name="Text 14"/>
-          <p:cNvSpPr txBox="1"/>
-          <p:nvPr/>
-        </p:nvSpPr>
-        <p:spPr>
-          <a:xfrm>
-            <a:off x="457200" y="4873752"/>
+          <p:cNvPr id="18" name="Text 13"/>
+          <p:cNvSpPr txBox="1"/>
+          <p:nvPr/>
+        </p:nvSpPr>
+        <p:spPr>
+          <a:xfrm>
+            <a:off x="457200" y="4937760"/>
             <a:ext cx="5120640" cy="274320"/>
           </a:xfrm>
           <a:prstGeom prst="rect">
@@ -6147,13 +6072,13 @@
       </p:sp>
       <p:sp>
         <p:nvSpPr>
-          <p:cNvPr id="19" name="Text 15"/>
-          <p:cNvSpPr txBox="1"/>
-          <p:nvPr/>
-        </p:nvSpPr>
-        <p:spPr>
-          <a:xfrm>
-            <a:off x="457200" y="5129784"/>
+          <p:cNvPr id="19" name="Text 14"/>
+          <p:cNvSpPr txBox="1"/>
+          <p:nvPr/>
+        </p:nvSpPr>
+        <p:spPr>
+          <a:xfrm>
+            <a:off x="457200" y="5193792"/>
             <a:ext cx="5120640" cy="411480"/>
           </a:xfrm>
           <a:prstGeom prst="rect">
@@ -6189,13 +6114,13 @@
       </p:sp>
       <p:sp>
         <p:nvSpPr>
-          <p:cNvPr id="20" name="Shape 16"/>
+          <p:cNvPr id="20" name="Shape 15"/>
           <p:cNvSpPr/>
           <p:nvPr/>
         </p:nvSpPr>
         <p:spPr>
           <a:xfrm>
-            <a:off x="457200" y="5586984"/>
+            <a:off x="457200" y="5577840"/>
             <a:ext cx="5120640" cy="0"/>
           </a:xfrm>
           <a:prstGeom prst="line">
@@ -6212,13 +6137,13 @@
       </p:sp>
       <p:sp>
         <p:nvSpPr>
-          <p:cNvPr id="21" name="Text 17"/>
-          <p:cNvSpPr txBox="1"/>
-          <p:nvPr/>
-        </p:nvSpPr>
-        <p:spPr>
-          <a:xfrm>
-            <a:off x="457200" y="5678424"/>
+          <p:cNvPr id="21" name="Text 16"/>
+          <p:cNvSpPr txBox="1"/>
+          <p:nvPr/>
+        </p:nvSpPr>
+        <p:spPr>
+          <a:xfrm>
+            <a:off x="457200" y="5669280"/>
             <a:ext cx="5120640" cy="274320"/>
           </a:xfrm>
           <a:prstGeom prst="rect">
@@ -6251,13 +6176,13 @@
       </p:sp>
       <p:sp>
         <p:nvSpPr>
-          <p:cNvPr id="22" name="Text 18"/>
-          <p:cNvSpPr txBox="1"/>
-          <p:nvPr/>
-        </p:nvSpPr>
-        <p:spPr>
-          <a:xfrm>
-            <a:off x="457200" y="5934456"/>
+          <p:cNvPr id="22" name="Text 17"/>
+          <p:cNvSpPr txBox="1"/>
+          <p:nvPr/>
+        </p:nvSpPr>
+        <p:spPr>
+          <a:xfrm>
+            <a:off x="457200" y="5925312"/>
             <a:ext cx="5120640" cy="411480"/>
           </a:xfrm>
           <a:prstGeom prst="rect">
@@ -6293,7 +6218,7 @@
       </p:sp>
       <p:sp>
         <p:nvSpPr>
-          <p:cNvPr id="23" name="Text 19"/>
+          <p:cNvPr id="23" name="Text 18"/>
           <p:cNvSpPr txBox="1"/>
           <p:nvPr/>
         </p:nvSpPr>
@@ -6362,48 +6287,9 @@
           <a:chExt cx="0" cy="0"/>
         </a:xfrm>
       </p:grpSpPr>
-      <p:sp>
-        <p:nvSpPr>
-          <p:cNvPr id="2" name="Text 0"/>
-          <p:cNvSpPr txBox="1"/>
-          <p:nvPr/>
-        </p:nvSpPr>
-        <p:spPr>
-          <a:xfrm>
-            <a:off x="6949440" y="0"/>
-            <a:ext cx="5486400" cy="6858000"/>
-          </a:xfrm>
-          <a:prstGeom prst="rect">
-            <a:avLst/>
-          </a:prstGeom>
-          <a:noFill/>
-          <a:ln/>
-        </p:spPr>
-        <p:txBody>
-          <a:bodyPr wrap="square" lIns="0" tIns="0" rIns="0" bIns="0" rtlCol="0" anchor="t"/>
-          <a:lstStyle/>
-          <a:p>
-            <a:pPr algn="r" indent="0" marL="0">
-              <a:buNone/>
-            </a:pPr>
-            <a:r>
-              <a:rPr lang="en-US" sz="36000" b="1" dirty="0">
-                <a:solidFill>
-                  <a:srgbClr val="141414"/>
-                </a:solidFill>
-                <a:latin typeface="Cambria" pitchFamily="34" charset="0"/>
-                <a:ea typeface="Cambria" pitchFamily="34" charset="-122"/>
-                <a:cs typeface="Cambria" pitchFamily="34" charset="-120"/>
-              </a:rPr>
-              <a:t>06</a:t>
-            </a:r>
-            <a:endParaRPr lang="en-US" sz="36000" dirty="0"/>
-          </a:p>
-        </p:txBody>
-      </p:sp>
       <p:pic>
         <p:nvPicPr>
-          <p:cNvPr id="3" name="Image 0" descr="/home/user/valletta-design-system/assets/logo/valletta-mark.png">    </p:cNvPr>
+          <p:cNvPr id="2" name="Image 0" descr="/home/user/valletta-design-system/assets/logo/valletta-mark-ghost.png">    </p:cNvPr>
           <p:cNvPicPr>
             <a:picLocks noChangeAspect="1"/>
           </p:cNvPicPr>
@@ -6417,8 +6303,32 @@
         </p:blipFill>
         <p:spPr>
           <a:xfrm>
+            <a:off x="7891272" y="502920"/>
+            <a:ext cx="5486400" cy="5839260"/>
+          </a:xfrm>
+          <a:prstGeom prst="rect">
+            <a:avLst/>
+          </a:prstGeom>
+        </p:spPr>
+      </p:pic>
+      <p:pic>
+        <p:nvPicPr>
+          <p:cNvPr id="3" name="Image 1" descr="/home/user/valletta-design-system/assets/logo/valletta-mark.png">    </p:cNvPr>
+          <p:cNvPicPr>
+            <a:picLocks noChangeAspect="1"/>
+          </p:cNvPicPr>
+          <p:nvPr/>
+        </p:nvPicPr>
+        <p:blipFill>
+          <a:blip r:embed="rId2"/>
+          <a:stretch>
+            <a:fillRect/>
+          </a:stretch>
+        </p:blipFill>
+        <p:spPr>
+          <a:xfrm>
             <a:off x="457200" y="365760"/>
-            <a:ext cx="365760" cy="389284"/>
+            <a:ext cx="548640" cy="583926"/>
           </a:xfrm>
           <a:prstGeom prst="rect">
             <a:avLst/>
@@ -6427,14 +6337,14 @@
       </p:pic>
       <p:sp>
         <p:nvSpPr>
-          <p:cNvPr id="4" name="Text 1"/>
-          <p:cNvSpPr txBox="1"/>
-          <p:nvPr/>
-        </p:nvSpPr>
-        <p:spPr>
-          <a:xfrm>
-            <a:off x="932688" y="329184"/>
-            <a:ext cx="2926080" cy="274320"/>
+          <p:cNvPr id="4" name="Text 0"/>
+          <p:cNvSpPr txBox="1"/>
+          <p:nvPr/>
+        </p:nvSpPr>
+        <p:spPr>
+          <a:xfrm>
+            <a:off x="1170432" y="347472"/>
+            <a:ext cx="3291840" cy="402336"/>
           </a:xfrm>
           <a:prstGeom prst="rect">
             <a:avLst/>
@@ -6450,7 +6360,7 @@
               <a:buNone/>
             </a:pPr>
             <a:r>
-              <a:rPr lang="en-US" sz="1500" spc="200" kern="0" dirty="0">
+              <a:rPr lang="en-US" sz="2200" spc="200" kern="0" dirty="0">
                 <a:solidFill>
                   <a:srgbClr val="FFFFFF"/>
                 </a:solidFill>
@@ -6460,20 +6370,20 @@
               </a:rPr>
               <a:t>VALLETTA</a:t>
             </a:r>
-            <a:endParaRPr lang="en-US" sz="1500" dirty="0"/>
-          </a:p>
-        </p:txBody>
-      </p:sp>
-      <p:sp>
-        <p:nvSpPr>
-          <p:cNvPr id="5" name="Text 2"/>
-          <p:cNvSpPr txBox="1"/>
-          <p:nvPr/>
-        </p:nvSpPr>
-        <p:spPr>
-          <a:xfrm>
-            <a:off x="932688" y="594360"/>
-            <a:ext cx="2926080" cy="219456"/>
+            <a:endParaRPr lang="en-US" sz="2200" dirty="0"/>
+          </a:p>
+        </p:txBody>
+      </p:sp>
+      <p:sp>
+        <p:nvSpPr>
+          <p:cNvPr id="5" name="Text 1"/>
+          <p:cNvSpPr txBox="1"/>
+          <p:nvPr/>
+        </p:nvSpPr>
+        <p:spPr>
+          <a:xfrm>
+            <a:off x="1170432" y="731520"/>
+            <a:ext cx="3291840" cy="274320"/>
           </a:xfrm>
           <a:prstGeom prst="rect">
             <a:avLst/>
@@ -6489,7 +6399,7 @@
               <a:buNone/>
             </a:pPr>
             <a:r>
-              <a:rPr lang="en-US" sz="750" b="1" spc="200" kern="0" dirty="0">
+              <a:rPr lang="en-US" sz="1100" b="1" spc="200" kern="0" dirty="0">
                 <a:solidFill>
                   <a:srgbClr val="5B5F66"/>
                 </a:solidFill>
@@ -6499,19 +6409,19 @@
               </a:rPr>
               <a:t>INDUSTRIES, INC.</a:t>
             </a:r>
-            <a:endParaRPr lang="en-US" sz="750" dirty="0"/>
-          </a:p>
-        </p:txBody>
-      </p:sp>
-      <p:sp>
-        <p:nvSpPr>
-          <p:cNvPr id="6" name="Text 3"/>
-          <p:cNvSpPr txBox="1"/>
-          <p:nvPr/>
-        </p:nvSpPr>
-        <p:spPr>
-          <a:xfrm>
-            <a:off x="457200" y="777240"/>
+            <a:endParaRPr lang="en-US" sz="1100" dirty="0"/>
+          </a:p>
+        </p:txBody>
+      </p:sp>
+      <p:sp>
+        <p:nvSpPr>
+          <p:cNvPr id="6" name="Text 2"/>
+          <p:cNvSpPr txBox="1"/>
+          <p:nvPr/>
+        </p:nvSpPr>
+        <p:spPr>
+          <a:xfrm>
+            <a:off x="457200" y="1005840"/>
             <a:ext cx="5486400" cy="320040"/>
           </a:xfrm>
           <a:prstGeom prst="rect">
@@ -6544,13 +6454,13 @@
       </p:sp>
       <p:sp>
         <p:nvSpPr>
-          <p:cNvPr id="7" name="Text 4"/>
-          <p:cNvSpPr txBox="1"/>
-          <p:nvPr/>
-        </p:nvSpPr>
-        <p:spPr>
-          <a:xfrm>
-            <a:off x="457200" y="1097280"/>
+          <p:cNvPr id="7" name="Text 3"/>
+          <p:cNvSpPr txBox="1"/>
+          <p:nvPr/>
+        </p:nvSpPr>
+        <p:spPr>
+          <a:xfrm>
+            <a:off x="457200" y="1325880"/>
             <a:ext cx="6675120" cy="685800"/>
           </a:xfrm>
           <a:prstGeom prst="rect">
@@ -6583,13 +6493,13 @@
       </p:sp>
       <p:sp>
         <p:nvSpPr>
-          <p:cNvPr id="8" name="Text 5"/>
-          <p:cNvSpPr txBox="1"/>
-          <p:nvPr/>
-        </p:nvSpPr>
-        <p:spPr>
-          <a:xfrm>
-            <a:off x="457200" y="1783080"/>
+          <p:cNvPr id="8" name="Text 4"/>
+          <p:cNvSpPr txBox="1"/>
+          <p:nvPr/>
+        </p:nvSpPr>
+        <p:spPr>
+          <a:xfrm>
+            <a:off x="457200" y="2011680"/>
             <a:ext cx="6675120" cy="457200"/>
           </a:xfrm>
           <a:prstGeom prst="rect">
@@ -6622,13 +6532,13 @@
       </p:sp>
       <p:sp>
         <p:nvSpPr>
-          <p:cNvPr id="9" name="Shape 6"/>
+          <p:cNvPr id="9" name="Shape 5"/>
           <p:cNvSpPr/>
           <p:nvPr/>
         </p:nvSpPr>
         <p:spPr>
           <a:xfrm>
-            <a:off x="457200" y="2606040"/>
+            <a:off x="457200" y="2788920"/>
             <a:ext cx="256032" cy="32004"/>
           </a:xfrm>
           <a:prstGeom prst="rect">
@@ -6642,13 +6552,13 @@
       </p:sp>
       <p:sp>
         <p:nvSpPr>
-          <p:cNvPr id="10" name="Shape 7"/>
+          <p:cNvPr id="10" name="Shape 6"/>
           <p:cNvSpPr/>
           <p:nvPr/>
         </p:nvSpPr>
         <p:spPr>
           <a:xfrm>
-            <a:off x="457200" y="2606040"/>
+            <a:off x="457200" y="2788920"/>
             <a:ext cx="32004" cy="256032"/>
           </a:xfrm>
           <a:prstGeom prst="rect">
@@ -6662,13 +6572,13 @@
       </p:sp>
       <p:sp>
         <p:nvSpPr>
-          <p:cNvPr id="11" name="Text 8"/>
-          <p:cNvSpPr txBox="1"/>
-          <p:nvPr/>
-        </p:nvSpPr>
-        <p:spPr>
-          <a:xfrm>
-            <a:off x="868680" y="2569464"/>
+          <p:cNvPr id="11" name="Text 7"/>
+          <p:cNvSpPr txBox="1"/>
+          <p:nvPr/>
+        </p:nvSpPr>
+        <p:spPr>
+          <a:xfrm>
+            <a:off x="868680" y="2752344"/>
             <a:ext cx="5623560" cy="384048"/>
           </a:xfrm>
           <a:prstGeom prst="rect">
@@ -6701,13 +6611,13 @@
       </p:sp>
       <p:sp>
         <p:nvSpPr>
-          <p:cNvPr id="12" name="Text 9"/>
-          <p:cNvSpPr txBox="1"/>
-          <p:nvPr/>
-        </p:nvSpPr>
-        <p:spPr>
-          <a:xfrm>
-            <a:off x="868680" y="2935224"/>
+          <p:cNvPr id="12" name="Text 8"/>
+          <p:cNvSpPr txBox="1"/>
+          <p:nvPr/>
+        </p:nvSpPr>
+        <p:spPr>
+          <a:xfrm>
+            <a:off x="868680" y="3118104"/>
             <a:ext cx="5623560" cy="640080"/>
           </a:xfrm>
           <a:prstGeom prst="rect">
@@ -6743,13 +6653,13 @@
       </p:sp>
       <p:sp>
         <p:nvSpPr>
-          <p:cNvPr id="13" name="Shape 10"/>
+          <p:cNvPr id="13" name="Shape 9"/>
           <p:cNvSpPr/>
           <p:nvPr/>
         </p:nvSpPr>
         <p:spPr>
           <a:xfrm>
-            <a:off x="457200" y="3685032"/>
+            <a:off x="457200" y="3840480"/>
             <a:ext cx="256032" cy="32004"/>
           </a:xfrm>
           <a:prstGeom prst="rect">
@@ -6763,13 +6673,13 @@
       </p:sp>
       <p:sp>
         <p:nvSpPr>
-          <p:cNvPr id="14" name="Shape 11"/>
+          <p:cNvPr id="14" name="Shape 10"/>
           <p:cNvSpPr/>
           <p:nvPr/>
         </p:nvSpPr>
         <p:spPr>
           <a:xfrm>
-            <a:off x="457200" y="3685032"/>
+            <a:off x="457200" y="3840480"/>
             <a:ext cx="32004" cy="256032"/>
           </a:xfrm>
           <a:prstGeom prst="rect">
@@ -6783,13 +6693,13 @@
       </p:sp>
       <p:sp>
         <p:nvSpPr>
-          <p:cNvPr id="15" name="Text 12"/>
-          <p:cNvSpPr txBox="1"/>
-          <p:nvPr/>
-        </p:nvSpPr>
-        <p:spPr>
-          <a:xfrm>
-            <a:off x="868680" y="3648456"/>
+          <p:cNvPr id="15" name="Text 11"/>
+          <p:cNvSpPr txBox="1"/>
+          <p:nvPr/>
+        </p:nvSpPr>
+        <p:spPr>
+          <a:xfrm>
+            <a:off x="868680" y="3803904"/>
             <a:ext cx="5623560" cy="384048"/>
           </a:xfrm>
           <a:prstGeom prst="rect">
@@ -6822,13 +6732,13 @@
       </p:sp>
       <p:sp>
         <p:nvSpPr>
-          <p:cNvPr id="16" name="Text 13"/>
-          <p:cNvSpPr txBox="1"/>
-          <p:nvPr/>
-        </p:nvSpPr>
-        <p:spPr>
-          <a:xfrm>
-            <a:off x="868680" y="4014216"/>
+          <p:cNvPr id="16" name="Text 12"/>
+          <p:cNvSpPr txBox="1"/>
+          <p:nvPr/>
+        </p:nvSpPr>
+        <p:spPr>
+          <a:xfrm>
+            <a:off x="868680" y="4169664"/>
             <a:ext cx="5623560" cy="640080"/>
           </a:xfrm>
           <a:prstGeom prst="rect">
@@ -6864,13 +6774,13 @@
       </p:sp>
       <p:sp>
         <p:nvSpPr>
-          <p:cNvPr id="17" name="Shape 14"/>
+          <p:cNvPr id="17" name="Shape 13"/>
           <p:cNvSpPr/>
           <p:nvPr/>
         </p:nvSpPr>
         <p:spPr>
           <a:xfrm>
-            <a:off x="457200" y="4764024"/>
+            <a:off x="457200" y="4892040"/>
             <a:ext cx="256032" cy="32004"/>
           </a:xfrm>
           <a:prstGeom prst="rect">
@@ -6884,13 +6794,13 @@
       </p:sp>
       <p:sp>
         <p:nvSpPr>
-          <p:cNvPr id="18" name="Shape 15"/>
+          <p:cNvPr id="18" name="Shape 14"/>
           <p:cNvSpPr/>
           <p:nvPr/>
         </p:nvSpPr>
         <p:spPr>
           <a:xfrm>
-            <a:off x="457200" y="4764024"/>
+            <a:off x="457200" y="4892040"/>
             <a:ext cx="32004" cy="256032"/>
           </a:xfrm>
           <a:prstGeom prst="rect">
@@ -6904,13 +6814,13 @@
       </p:sp>
       <p:sp>
         <p:nvSpPr>
-          <p:cNvPr id="19" name="Text 16"/>
-          <p:cNvSpPr txBox="1"/>
-          <p:nvPr/>
-        </p:nvSpPr>
-        <p:spPr>
-          <a:xfrm>
-            <a:off x="868680" y="4727448"/>
+          <p:cNvPr id="19" name="Text 15"/>
+          <p:cNvSpPr txBox="1"/>
+          <p:nvPr/>
+        </p:nvSpPr>
+        <p:spPr>
+          <a:xfrm>
+            <a:off x="868680" y="4855464"/>
             <a:ext cx="5623560" cy="384048"/>
           </a:xfrm>
           <a:prstGeom prst="rect">
@@ -6943,13 +6853,13 @@
       </p:sp>
       <p:sp>
         <p:nvSpPr>
-          <p:cNvPr id="20" name="Text 17"/>
-          <p:cNvSpPr txBox="1"/>
-          <p:nvPr/>
-        </p:nvSpPr>
-        <p:spPr>
-          <a:xfrm>
-            <a:off x="868680" y="5093208"/>
+          <p:cNvPr id="20" name="Text 16"/>
+          <p:cNvSpPr txBox="1"/>
+          <p:nvPr/>
+        </p:nvSpPr>
+        <p:spPr>
+          <a:xfrm>
+            <a:off x="868680" y="5221224"/>
             <a:ext cx="5623560" cy="640080"/>
           </a:xfrm>
           <a:prstGeom prst="rect">
@@ -6985,7 +6895,7 @@
       </p:sp>
       <p:sp>
         <p:nvSpPr>
-          <p:cNvPr id="21" name="Shape 18"/>
+          <p:cNvPr id="21" name="Shape 17"/>
           <p:cNvSpPr/>
           <p:nvPr/>
         </p:nvSpPr>
@@ -7005,7 +6915,7 @@
       </p:sp>
       <p:sp>
         <p:nvSpPr>
-          <p:cNvPr id="22" name="Shape 19"/>
+          <p:cNvPr id="22" name="Shape 18"/>
           <p:cNvSpPr/>
           <p:nvPr/>
         </p:nvSpPr>
@@ -7025,7 +6935,7 @@
       </p:sp>
       <p:sp>
         <p:nvSpPr>
-          <p:cNvPr id="23" name="Shape 20"/>
+          <p:cNvPr id="23" name="Shape 19"/>
           <p:cNvSpPr/>
           <p:nvPr/>
         </p:nvSpPr>
@@ -7045,7 +6955,7 @@
       </p:sp>
       <p:sp>
         <p:nvSpPr>
-          <p:cNvPr id="24" name="Text 21"/>
+          <p:cNvPr id="24" name="Text 20"/>
           <p:cNvSpPr txBox="1"/>
           <p:nvPr/>
         </p:nvSpPr>
@@ -7084,7 +6994,7 @@
       </p:sp>
       <p:sp>
         <p:nvSpPr>
-          <p:cNvPr id="25" name="Text 22"/>
+          <p:cNvPr id="25" name="Text 21"/>
           <p:cNvSpPr txBox="1"/>
           <p:nvPr/>
         </p:nvSpPr>
@@ -7166,7 +7076,7 @@
       </p:sp>
       <p:sp>
         <p:nvSpPr>
-          <p:cNvPr id="26" name="Text 23"/>
+          <p:cNvPr id="26" name="Text 22"/>
           <p:cNvSpPr txBox="1"/>
           <p:nvPr/>
         </p:nvSpPr>
@@ -7205,7 +7115,7 @@
       </p:sp>
       <p:sp>
         <p:nvSpPr>
-          <p:cNvPr id="27" name="Text 24"/>
+          <p:cNvPr id="27" name="Text 23"/>
           <p:cNvSpPr txBox="1"/>
           <p:nvPr/>
         </p:nvSpPr>
@@ -7307,7 +7217,7 @@
       </p:sp>
       <p:sp>
         <p:nvSpPr>
-          <p:cNvPr id="28" name="Shape 25"/>
+          <p:cNvPr id="28" name="Shape 24"/>
           <p:cNvSpPr/>
           <p:nvPr/>
         </p:nvSpPr>
@@ -7330,7 +7240,7 @@
       </p:sp>
       <p:sp>
         <p:nvSpPr>
-          <p:cNvPr id="29" name="Text 26"/>
+          <p:cNvPr id="29" name="Text 25"/>
           <p:cNvSpPr txBox="1"/>
           <p:nvPr/>
         </p:nvSpPr>

</xml_diff>